<commit_message>
fix(presentation): update theme to Teal/Sky, fix slide overflow bounds, add links & presenter attribution (~ Keshav)
</commit_message>
<xml_diff>
--- a/presentation.pptx
+++ b/presentation.pptx
@@ -3122,7 +3122,7 @@
             <a:avLst/>
           </a:prstGeom>
           <a:solidFill>
-            <a:srgbClr val="0F172A"/>
+            <a:srgbClr val="090D16"/>
           </a:solidFill>
           <a:ln>
             <a:noFill/>
@@ -3158,8 +3158,8 @@
         </p:nvSpPr>
         <p:spPr>
           <a:xfrm>
-            <a:off x="731520" y="365760"/>
-            <a:ext cx="10728655" cy="822960"/>
+            <a:off x="548640" y="274320"/>
+            <a:ext cx="11094415" cy="685800"/>
           </a:xfrm>
           <a:prstGeom prst="rect">
             <a:avLst/>
@@ -3167,15 +3167,15 @@
           <a:noFill/>
         </p:spPr>
         <p:txBody>
-          <a:bodyPr wrap="square">
+          <a:bodyPr wrap="square" lIns="0" tIns="0" rIns="0" bIns="0">
             <a:spAutoFit/>
           </a:bodyPr>
           <a:lstStyle/>
           <a:p>
             <a:pPr>
-              <a:defRPr sz="2600" b="1">
-                <a:solidFill>
-                  <a:srgbClr val="818CF8"/>
+              <a:defRPr sz="2200" b="1">
+                <a:solidFill>
+                  <a:srgbClr val="38BDF8"/>
                 </a:solidFill>
                 <a:latin typeface="Segoe UI"/>
               </a:defRPr>
@@ -3194,14 +3194,14 @@
         </p:nvSpPr>
         <p:spPr>
           <a:xfrm>
-            <a:off x="731520" y="1188720"/>
-            <a:ext cx="10728655" cy="36576"/>
+            <a:off x="548640" y="1005840"/>
+            <a:ext cx="11094415" cy="27432"/>
           </a:xfrm>
           <a:prstGeom prst="rect">
             <a:avLst/>
           </a:prstGeom>
           <a:solidFill>
-            <a:srgbClr val="38BDF8"/>
+            <a:srgbClr val="0D9488"/>
           </a:solidFill>
           <a:ln>
             <a:noFill/>
@@ -3237,8 +3237,8 @@
         </p:nvSpPr>
         <p:spPr>
           <a:xfrm>
-            <a:off x="731520" y="1371600"/>
-            <a:ext cx="10728655" cy="4937760"/>
+            <a:off x="548640" y="1143000"/>
+            <a:ext cx="11094415" cy="5303520"/>
           </a:xfrm>
           <a:prstGeom prst="rect">
             <a:avLst/>
@@ -3246,16 +3246,16 @@
           <a:noFill/>
         </p:spPr>
         <p:txBody>
-          <a:bodyPr wrap="square">
+          <a:bodyPr wrap="square" lIns="0" tIns="0" rIns="0" bIns="0">
             <a:spAutoFit/>
           </a:bodyPr>
           <a:lstStyle/>
           <a:p>
             <a:pPr>
               <a:spcAft>
-                <a:spcPts val="600"/>
-              </a:spcAft>
-              <a:defRPr sz="1400" i="1">
+                <a:spcPts val="400"/>
+              </a:spcAft>
+              <a:defRPr sz="1300" i="1">
                 <a:solidFill>
                   <a:srgbClr val="94A3B8"/>
                 </a:solidFill>
@@ -3263,15 +3263,15 @@
               </a:defRPr>
             </a:pPr>
             <a:r>
-              <a:t>**Master Slide Deck &amp; Technical Blueprint**</a:t>
-            </a:r>
-          </a:p>
-          <a:p>
-            <a:pPr>
-              <a:spcAft>
-                <a:spcPts val="600"/>
-              </a:spcAft>
-              <a:defRPr sz="1400" i="1">
+              <a:t>Master Slide Deck &amp; Technical Blueprint</a:t>
+            </a:r>
+          </a:p>
+          <a:p>
+            <a:pPr>
+              <a:spcAft>
+                <a:spcPts val="400"/>
+              </a:spcAft>
+              <a:defRPr sz="1300" i="1">
                 <a:solidFill>
                   <a:srgbClr val="94A3B8"/>
                 </a:solidFill>
@@ -3285,9 +3285,9 @@
           <a:p>
             <a:pPr>
               <a:spcAft>
-                <a:spcPts val="600"/>
-              </a:spcAft>
-              <a:defRPr sz="1400" i="1">
+                <a:spcPts val="400"/>
+              </a:spcAft>
+              <a:defRPr sz="1300" i="1">
                 <a:solidFill>
                   <a:srgbClr val="94A3B8"/>
                 </a:solidFill>
@@ -3295,7 +3295,39 @@
               </a:defRPr>
             </a:pPr>
             <a:r>
-              <a:t>**Target Audience**: Technical Mentors, System Architects, &amp; Engineering Evaluation Panels</a:t>
+              <a:t>Author: ~ Keshav Kakani</a:t>
+            </a:r>
+          </a:p>
+          <a:p>
+            <a:pPr>
+              <a:spcAft>
+                <a:spcPts val="400"/>
+              </a:spcAft>
+              <a:defRPr sz="1300" i="1">
+                <a:solidFill>
+                  <a:srgbClr val="94A3B8"/>
+                </a:solidFill>
+                <a:latin typeface="Segoe UI"/>
+              </a:defRPr>
+            </a:pPr>
+            <a:r>
+              <a:t>GitHub Repository: [github.com/keshav9926/First-Impression-](https://github.com/keshav9926/First-Impression-)</a:t>
+            </a:r>
+          </a:p>
+          <a:p>
+            <a:pPr>
+              <a:spcAft>
+                <a:spcPts val="400"/>
+              </a:spcAft>
+              <a:defRPr sz="1300" i="1">
+                <a:solidFill>
+                  <a:srgbClr val="94A3B8"/>
+                </a:solidFill>
+                <a:latin typeface="Segoe UI"/>
+              </a:defRPr>
+            </a:pPr>
+            <a:r>
+              <a:t>Live Demos: [Vortexify Report](https://firstimpressione.netlify.app/vortexify) | [KAINest Report](https://firstimpressione.netlify.app/kainest)</a:t>
             </a:r>
           </a:p>
         </p:txBody>
@@ -3333,7 +3365,7 @@
             <a:avLst/>
           </a:prstGeom>
           <a:solidFill>
-            <a:srgbClr val="0F172A"/>
+            <a:srgbClr val="090D16"/>
           </a:solidFill>
           <a:ln>
             <a:noFill/>
@@ -3369,8 +3401,8 @@
         </p:nvSpPr>
         <p:spPr>
           <a:xfrm>
-            <a:off x="731520" y="365760"/>
-            <a:ext cx="10728655" cy="822960"/>
+            <a:off x="548640" y="274320"/>
+            <a:ext cx="11094415" cy="685800"/>
           </a:xfrm>
           <a:prstGeom prst="rect">
             <a:avLst/>
@@ -3378,15 +3410,15 @@
           <a:noFill/>
         </p:spPr>
         <p:txBody>
-          <a:bodyPr wrap="square">
+          <a:bodyPr wrap="square" lIns="0" tIns="0" rIns="0" bIns="0">
             <a:spAutoFit/>
           </a:bodyPr>
           <a:lstStyle/>
           <a:p>
             <a:pPr>
-              <a:defRPr sz="2600" b="1">
-                <a:solidFill>
-                  <a:srgbClr val="818CF8"/>
+              <a:defRPr sz="2200" b="1">
+                <a:solidFill>
+                  <a:srgbClr val="38BDF8"/>
                 </a:solidFill>
                 <a:latin typeface="Segoe UI"/>
               </a:defRPr>
@@ -3405,14 +3437,14 @@
         </p:nvSpPr>
         <p:spPr>
           <a:xfrm>
-            <a:off x="731520" y="1188720"/>
-            <a:ext cx="10728655" cy="36576"/>
+            <a:off x="548640" y="1005840"/>
+            <a:ext cx="11094415" cy="27432"/>
           </a:xfrm>
           <a:prstGeom prst="rect">
             <a:avLst/>
           </a:prstGeom>
           <a:solidFill>
-            <a:srgbClr val="38BDF8"/>
+            <a:srgbClr val="0D9488"/>
           </a:solidFill>
           <a:ln>
             <a:noFill/>
@@ -3448,8 +3480,8 @@
         </p:nvSpPr>
         <p:spPr>
           <a:xfrm>
-            <a:off x="731520" y="1371600"/>
-            <a:ext cx="5120640" cy="4937760"/>
+            <a:off x="548640" y="1143000"/>
+            <a:ext cx="5120640" cy="5303520"/>
           </a:xfrm>
           <a:prstGeom prst="rect">
             <a:avLst/>
@@ -3457,48 +3489,48 @@
           <a:noFill/>
         </p:spPr>
         <p:txBody>
-          <a:bodyPr wrap="square">
+          <a:bodyPr wrap="square" lIns="0" tIns="0" rIns="0" bIns="0">
             <a:spAutoFit/>
           </a:bodyPr>
           <a:lstStyle/>
           <a:p>
             <a:pPr>
               <a:spcAft>
-                <a:spcPts val="800"/>
-              </a:spcAft>
-              <a:defRPr sz="2000" b="1">
-                <a:solidFill>
-                  <a:srgbClr val="94A3B8"/>
-                </a:solidFill>
-                <a:latin typeface="Segoe UI"/>
-              </a:defRPr>
-            </a:pPr>
-            <a:r>
-              <a:t>**Reason + Act + Observe Autonomous Exploration (`app/agent/react.py`)**</a:t>
-            </a:r>
-          </a:p>
-          <a:p>
-            <a:pPr>
-              <a:spcAft>
                 <a:spcPts val="400"/>
               </a:spcAft>
-              <a:defRPr sz="1400">
-                <a:solidFill>
-                  <a:srgbClr val="F1F5F9"/>
-                </a:solidFill>
-                <a:latin typeface="Segoe UI"/>
-              </a:defRPr>
-            </a:pPr>
-            <a:r>
-              <a:t>• Architecture: A hand-rolled ReAct agent loop that autonomously investigates an ingested domain prior to report generation.</a:t>
-            </a:r>
-          </a:p>
-          <a:p>
-            <a:pPr>
-              <a:spcAft>
-                <a:spcPts val="400"/>
-              </a:spcAft>
-              <a:defRPr sz="1400">
+              <a:defRPr sz="1600" b="1">
+                <a:solidFill>
+                  <a:srgbClr val="2DD4BF"/>
+                </a:solidFill>
+                <a:latin typeface="Segoe UI"/>
+              </a:defRPr>
+            </a:pPr>
+            <a:r>
+              <a:t>Reason + Act + Observe Autonomous Exploration (`app/agent/react.py`)</a:t>
+            </a:r>
+          </a:p>
+          <a:p>
+            <a:pPr>
+              <a:spcAft>
+                <a:spcPts val="250"/>
+              </a:spcAft>
+              <a:defRPr sz="1200">
+                <a:solidFill>
+                  <a:srgbClr val="F1F5F9"/>
+                </a:solidFill>
+                <a:latin typeface="Segoe UI"/>
+              </a:defRPr>
+            </a:pPr>
+            <a:r>
+              <a:t>• Architecture: Hand-rolled ReAct agent loop autonomously investigating an ingested domain prior to report generation.</a:t>
+            </a:r>
+          </a:p>
+          <a:p>
+            <a:pPr>
+              <a:spcAft>
+                <a:spcPts val="250"/>
+              </a:spcAft>
+              <a:defRPr sz="1200">
                 <a:solidFill>
                   <a:srgbClr val="F1F5F9"/>
                 </a:solidFill>
@@ -3519,18 +3551,18 @@
         </p:nvSpPr>
         <p:spPr>
           <a:xfrm>
-            <a:off x="6035040" y="1371600"/>
-            <a:ext cx="5394960" cy="4937760"/>
+            <a:off x="5852160" y="1143000"/>
+            <a:ext cx="5760720" cy="5303520"/>
           </a:xfrm>
           <a:prstGeom prst="roundRect">
             <a:avLst/>
           </a:prstGeom>
           <a:solidFill>
-            <a:srgbClr val="1E293B"/>
+            <a:srgbClr val="0F172A"/>
           </a:solidFill>
           <a:ln>
             <a:solidFill>
-              <a:srgbClr val="38BDF8"/>
+              <a:srgbClr val="0D9488"/>
             </a:solidFill>
           </a:ln>
         </p:spPr>
@@ -3564,8 +3596,8 @@
         </p:nvSpPr>
         <p:spPr>
           <a:xfrm>
-            <a:off x="6217920" y="1463040"/>
-            <a:ext cx="5029200" cy="4754880"/>
+            <a:off x="5989320" y="1234440"/>
+            <a:ext cx="5486400" cy="5120640"/>
           </a:xfrm>
           <a:prstGeom prst="rect">
             <a:avLst/>
@@ -3573,13 +3605,13 @@
           <a:noFill/>
         </p:spPr>
         <p:txBody>
-          <a:bodyPr wrap="square">
+          <a:bodyPr wrap="square" lIns="0" tIns="0" rIns="0" bIns="0">
             <a:spAutoFit/>
           </a:bodyPr>
           <a:lstStyle/>
           <a:p>
             <a:pPr>
-              <a:defRPr sz="1100">
+              <a:defRPr sz="950">
                 <a:solidFill>
                   <a:srgbClr val="E2E8F0"/>
                 </a:solidFill>
@@ -3645,7 +3677,7 @@
             <a:avLst/>
           </a:prstGeom>
           <a:solidFill>
-            <a:srgbClr val="0F172A"/>
+            <a:srgbClr val="090D16"/>
           </a:solidFill>
           <a:ln>
             <a:noFill/>
@@ -3681,8 +3713,8 @@
         </p:nvSpPr>
         <p:spPr>
           <a:xfrm>
-            <a:off x="731520" y="365760"/>
-            <a:ext cx="10728655" cy="822960"/>
+            <a:off x="548640" y="274320"/>
+            <a:ext cx="11094415" cy="685800"/>
           </a:xfrm>
           <a:prstGeom prst="rect">
             <a:avLst/>
@@ -3690,15 +3722,15 @@
           <a:noFill/>
         </p:spPr>
         <p:txBody>
-          <a:bodyPr wrap="square">
+          <a:bodyPr wrap="square" lIns="0" tIns="0" rIns="0" bIns="0">
             <a:spAutoFit/>
           </a:bodyPr>
           <a:lstStyle/>
           <a:p>
             <a:pPr>
-              <a:defRPr sz="2600" b="1">
-                <a:solidFill>
-                  <a:srgbClr val="818CF8"/>
+              <a:defRPr sz="2200" b="1">
+                <a:solidFill>
+                  <a:srgbClr val="38BDF8"/>
                 </a:solidFill>
                 <a:latin typeface="Segoe UI"/>
               </a:defRPr>
@@ -3717,14 +3749,14 @@
         </p:nvSpPr>
         <p:spPr>
           <a:xfrm>
-            <a:off x="731520" y="1188720"/>
-            <a:ext cx="10728655" cy="36576"/>
+            <a:off x="548640" y="1005840"/>
+            <a:ext cx="11094415" cy="27432"/>
           </a:xfrm>
           <a:prstGeom prst="rect">
             <a:avLst/>
           </a:prstGeom>
           <a:solidFill>
-            <a:srgbClr val="38BDF8"/>
+            <a:srgbClr val="0D9488"/>
           </a:solidFill>
           <a:ln>
             <a:noFill/>
@@ -3760,8 +3792,8 @@
         </p:nvSpPr>
         <p:spPr>
           <a:xfrm>
-            <a:off x="731520" y="1371600"/>
-            <a:ext cx="10728655" cy="4937760"/>
+            <a:off x="548640" y="1143000"/>
+            <a:ext cx="11094415" cy="5303520"/>
           </a:xfrm>
           <a:prstGeom prst="rect">
             <a:avLst/>
@@ -3769,32 +3801,32 @@
           <a:noFill/>
         </p:spPr>
         <p:txBody>
-          <a:bodyPr wrap="square">
+          <a:bodyPr wrap="square" lIns="0" tIns="0" rIns="0" bIns="0">
             <a:spAutoFit/>
           </a:bodyPr>
           <a:lstStyle/>
           <a:p>
             <a:pPr>
               <a:spcAft>
-                <a:spcPts val="800"/>
-              </a:spcAft>
-              <a:defRPr sz="2000" b="1">
-                <a:solidFill>
-                  <a:srgbClr val="94A3B8"/>
-                </a:solidFill>
-                <a:latin typeface="Segoe UI"/>
-              </a:defRPr>
-            </a:pPr>
-            <a:r>
-              <a:t>**Bounded Exploration Tool Registry (`app/agent/tools.py`)**</a:t>
-            </a:r>
-          </a:p>
-          <a:p>
-            <a:pPr>
-              <a:spcAft>
                 <a:spcPts val="400"/>
               </a:spcAft>
-              <a:defRPr sz="1400">
+              <a:defRPr sz="1700" b="1">
+                <a:solidFill>
+                  <a:srgbClr val="2DD4BF"/>
+                </a:solidFill>
+                <a:latin typeface="Segoe UI"/>
+              </a:defRPr>
+            </a:pPr>
+            <a:r>
+              <a:t>Bounded Exploration Tool Registry (`app/agent/tools.py`)</a:t>
+            </a:r>
+          </a:p>
+          <a:p>
+            <a:pPr>
+              <a:spcAft>
+                <a:spcPts val="250"/>
+              </a:spcAft>
+              <a:defRPr sz="1300">
                 <a:solidFill>
                   <a:srgbClr val="F1F5F9"/>
                 </a:solidFill>
@@ -3808,9 +3840,9 @@
           <a:p>
             <a:pPr>
               <a:spcAft>
-                <a:spcPts val="400"/>
-              </a:spcAft>
-              <a:defRPr sz="1400">
+                <a:spcPts val="250"/>
+              </a:spcAft>
+              <a:defRPr sz="1300">
                 <a:solidFill>
                   <a:srgbClr val="F1F5F9"/>
                 </a:solidFill>
@@ -3824,9 +3856,9 @@
           <a:p>
             <a:pPr>
               <a:spcAft>
-                <a:spcPts val="400"/>
-              </a:spcAft>
-              <a:defRPr sz="1400">
+                <a:spcPts val="250"/>
+              </a:spcAft>
+              <a:defRPr sz="1300">
                 <a:solidFill>
                   <a:srgbClr val="F1F5F9"/>
                 </a:solidFill>
@@ -3840,9 +3872,9 @@
           <a:p>
             <a:pPr>
               <a:spcAft>
-                <a:spcPts val="400"/>
-              </a:spcAft>
-              <a:defRPr sz="1400">
+                <a:spcPts val="250"/>
+              </a:spcAft>
+              <a:defRPr sz="1300">
                 <a:solidFill>
                   <a:srgbClr val="F1F5F9"/>
                 </a:solidFill>
@@ -3856,9 +3888,9 @@
           <a:p>
             <a:pPr>
               <a:spcAft>
-                <a:spcPts val="400"/>
-              </a:spcAft>
-              <a:defRPr sz="1400">
+                <a:spcPts val="250"/>
+              </a:spcAft>
+              <a:defRPr sz="1300">
                 <a:solidFill>
                   <a:srgbClr val="F1F5F9"/>
                 </a:solidFill>
@@ -3872,25 +3904,25 @@
           <a:p>
             <a:pPr>
               <a:spcAft>
-                <a:spcPts val="400"/>
-              </a:spcAft>
-              <a:defRPr sz="1400">
-                <a:solidFill>
-                  <a:srgbClr val="F1F5F9"/>
-                </a:solidFill>
-                <a:latin typeface="Segoe UI"/>
-              </a:defRPr>
-            </a:pPr>
-            <a:r>
-              <a:t>• *Behavior*: Fetches clean extracted body text of a specific URL. Capped at 4,000 characters. Prepends extracted AST Headings (`h1..h3`), navbar CTAs, and VLM visual screenshot captions to the top of the observation.</a:t>
-            </a:r>
-          </a:p>
-          <a:p>
-            <a:pPr>
-              <a:spcAft>
-                <a:spcPts val="400"/>
-              </a:spcAft>
-              <a:defRPr sz="1400">
+                <a:spcPts val="250"/>
+              </a:spcAft>
+              <a:defRPr sz="1300">
+                <a:solidFill>
+                  <a:srgbClr val="F1F5F9"/>
+                </a:solidFill>
+                <a:latin typeface="Segoe UI"/>
+              </a:defRPr>
+            </a:pPr>
+            <a:r>
+              <a:t>• *Behavior*: Fetches clean extracted body text of a specific URL. Capped at 4,000 characters. Prepends AST Headings (`h1..h3`), navbar CTAs, and VLM visual screenshot captions to the top of the observation.</a:t>
+            </a:r>
+          </a:p>
+          <a:p>
+            <a:pPr>
+              <a:spcAft>
+                <a:spcPts val="250"/>
+              </a:spcAft>
+              <a:defRPr sz="1300">
                 <a:solidFill>
                   <a:srgbClr val="F1F5F9"/>
                 </a:solidFill>
@@ -3904,9 +3936,9 @@
           <a:p>
             <a:pPr>
               <a:spcAft>
-                <a:spcPts val="400"/>
-              </a:spcAft>
-              <a:defRPr sz="1400">
+                <a:spcPts val="250"/>
+              </a:spcAft>
+              <a:defRPr sz="1300">
                 <a:solidFill>
                   <a:srgbClr val="F1F5F9"/>
                 </a:solidFill>
@@ -3920,9 +3952,9 @@
           <a:p>
             <a:pPr>
               <a:spcAft>
-                <a:spcPts val="400"/>
-              </a:spcAft>
-              <a:defRPr sz="1400">
+                <a:spcPts val="250"/>
+              </a:spcAft>
+              <a:defRPr sz="1300">
                 <a:solidFill>
                   <a:srgbClr val="F1F5F9"/>
                 </a:solidFill>
@@ -3968,7 +4000,7 @@
             <a:avLst/>
           </a:prstGeom>
           <a:solidFill>
-            <a:srgbClr val="0F172A"/>
+            <a:srgbClr val="090D16"/>
           </a:solidFill>
           <a:ln>
             <a:noFill/>
@@ -4004,8 +4036,8 @@
         </p:nvSpPr>
         <p:spPr>
           <a:xfrm>
-            <a:off x="731520" y="365760"/>
-            <a:ext cx="10728655" cy="822960"/>
+            <a:off x="548640" y="274320"/>
+            <a:ext cx="11094415" cy="685800"/>
           </a:xfrm>
           <a:prstGeom prst="rect">
             <a:avLst/>
@@ -4013,15 +4045,15 @@
           <a:noFill/>
         </p:spPr>
         <p:txBody>
-          <a:bodyPr wrap="square">
+          <a:bodyPr wrap="square" lIns="0" tIns="0" rIns="0" bIns="0">
             <a:spAutoFit/>
           </a:bodyPr>
           <a:lstStyle/>
           <a:p>
             <a:pPr>
-              <a:defRPr sz="2600" b="1">
-                <a:solidFill>
-                  <a:srgbClr val="818CF8"/>
+              <a:defRPr sz="2200" b="1">
+                <a:solidFill>
+                  <a:srgbClr val="38BDF8"/>
                 </a:solidFill>
                 <a:latin typeface="Segoe UI"/>
               </a:defRPr>
@@ -4040,14 +4072,14 @@
         </p:nvSpPr>
         <p:spPr>
           <a:xfrm>
-            <a:off x="731520" y="1188720"/>
-            <a:ext cx="10728655" cy="36576"/>
+            <a:off x="548640" y="1005840"/>
+            <a:ext cx="11094415" cy="27432"/>
           </a:xfrm>
           <a:prstGeom prst="rect">
             <a:avLst/>
           </a:prstGeom>
           <a:solidFill>
-            <a:srgbClr val="38BDF8"/>
+            <a:srgbClr val="0D9488"/>
           </a:solidFill>
           <a:ln>
             <a:noFill/>
@@ -4083,8 +4115,8 @@
         </p:nvSpPr>
         <p:spPr>
           <a:xfrm>
-            <a:off x="731520" y="1371600"/>
-            <a:ext cx="10728655" cy="4937760"/>
+            <a:off x="548640" y="1143000"/>
+            <a:ext cx="11094415" cy="5303520"/>
           </a:xfrm>
           <a:prstGeom prst="rect">
             <a:avLst/>
@@ -4092,64 +4124,64 @@
           <a:noFill/>
         </p:spPr>
         <p:txBody>
-          <a:bodyPr wrap="square">
+          <a:bodyPr wrap="square" lIns="0" tIns="0" rIns="0" bIns="0">
             <a:spAutoFit/>
           </a:bodyPr>
           <a:lstStyle/>
           <a:p>
             <a:pPr>
               <a:spcAft>
-                <a:spcPts val="800"/>
-              </a:spcAft>
-              <a:defRPr sz="2000" b="1">
-                <a:solidFill>
-                  <a:srgbClr val="94A3B8"/>
-                </a:solidFill>
-                <a:latin typeface="Segoe UI"/>
-              </a:defRPr>
-            </a:pPr>
-            <a:r>
-              <a:t>**System Prompts &amp; Strict Output Guarantees (`app/agent/prompts.py`)**</a:t>
-            </a:r>
-          </a:p>
-          <a:p>
-            <a:pPr>
-              <a:spcAft>
                 <a:spcPts val="400"/>
               </a:spcAft>
-              <a:defRPr sz="1400">
-                <a:solidFill>
-                  <a:srgbClr val="F1F5F9"/>
-                </a:solidFill>
-                <a:latin typeface="Segoe UI"/>
-              </a:defRPr>
-            </a:pPr>
-            <a:r>
-              <a:t>• Exploration System Prompt: Commands the ReAct agent to adopt a systematic discovery mindset—exploring pricing, features, security, documentation, and about/team pages.</a:t>
-            </a:r>
-          </a:p>
-          <a:p>
-            <a:pPr>
-              <a:spcAft>
-                <a:spcPts val="400"/>
-              </a:spcAft>
-              <a:defRPr sz="1400">
-                <a:solidFill>
-                  <a:srgbClr val="F1F5F9"/>
-                </a:solidFill>
-                <a:latin typeface="Segoe UI"/>
-              </a:defRPr>
-            </a:pPr>
-            <a:r>
-              <a:t>• Synthesis Prompt: Directs the LLM to synthesize structured JSON adhering strictly to the `FirstImpressionReport` Pydantic model.</a:t>
-            </a:r>
-          </a:p>
-          <a:p>
-            <a:pPr>
-              <a:spcAft>
-                <a:spcPts val="400"/>
-              </a:spcAft>
-              <a:defRPr sz="1400">
+              <a:defRPr sz="1700" b="1">
+                <a:solidFill>
+                  <a:srgbClr val="2DD4BF"/>
+                </a:solidFill>
+                <a:latin typeface="Segoe UI"/>
+              </a:defRPr>
+            </a:pPr>
+            <a:r>
+              <a:t>System Prompts &amp; Strict Output Guarantees (`app/agent/prompts.py`)</a:t>
+            </a:r>
+          </a:p>
+          <a:p>
+            <a:pPr>
+              <a:spcAft>
+                <a:spcPts val="250"/>
+              </a:spcAft>
+              <a:defRPr sz="1300">
+                <a:solidFill>
+                  <a:srgbClr val="F1F5F9"/>
+                </a:solidFill>
+                <a:latin typeface="Segoe UI"/>
+              </a:defRPr>
+            </a:pPr>
+            <a:r>
+              <a:t>• Exploration System Prompt: Commands the ReAct agent to adopt a systematic discovery mindset—exploring pricing, features, security, documentation, and team pages.</a:t>
+            </a:r>
+          </a:p>
+          <a:p>
+            <a:pPr>
+              <a:spcAft>
+                <a:spcPts val="250"/>
+              </a:spcAft>
+              <a:defRPr sz="1300">
+                <a:solidFill>
+                  <a:srgbClr val="F1F5F9"/>
+                </a:solidFill>
+                <a:latin typeface="Segoe UI"/>
+              </a:defRPr>
+            </a:pPr>
+            <a:r>
+              <a:t>• Synthesis Prompt: Directs LLM to synthesize structured JSON adhering strictly to `FirstImpressionReport` Pydantic model.</a:t>
+            </a:r>
+          </a:p>
+          <a:p>
+            <a:pPr>
+              <a:spcAft>
+                <a:spcPts val="250"/>
+              </a:spcAft>
+              <a:defRPr sz="1300">
                 <a:solidFill>
                   <a:srgbClr val="F1F5F9"/>
                 </a:solidFill>
@@ -4163,49 +4195,49 @@
           <a:p>
             <a:pPr>
               <a:spcAft>
-                <a:spcPts val="400"/>
-              </a:spcAft>
-              <a:defRPr sz="1400">
-                <a:solidFill>
-                  <a:srgbClr val="F1F5F9"/>
-                </a:solidFill>
-                <a:latin typeface="Segoe UI"/>
-              </a:defRPr>
-            </a:pPr>
-            <a:r>
-              <a:t>• No Unbacked Knowledge: Forces LLM to rely *exclusively* on tool-returned observations.</a:t>
-            </a:r>
-          </a:p>
-          <a:p>
-            <a:pPr>
-              <a:spcAft>
-                <a:spcPts val="400"/>
-              </a:spcAft>
-              <a:defRPr sz="1400">
-                <a:solidFill>
-                  <a:srgbClr val="F1F5F9"/>
-                </a:solidFill>
-                <a:latin typeface="Segoe UI"/>
-              </a:defRPr>
-            </a:pPr>
-            <a:r>
-              <a:t>• Verbatim Source URL Binding: Every observation object must include an explicit `source_url` field pointing to a real URL returned in the exploration phase.</a:t>
-            </a:r>
-          </a:p>
-          <a:p>
-            <a:pPr>
-              <a:spcAft>
-                <a:spcPts val="400"/>
-              </a:spcAft>
-              <a:defRPr sz="1400">
-                <a:solidFill>
-                  <a:srgbClr val="F1F5F9"/>
-                </a:solidFill>
-                <a:latin typeface="Segoe UI"/>
-              </a:defRPr>
-            </a:pPr>
-            <a:r>
-              <a:t>• Tolerant JSON Parsing (`llm_pool.py`): Strips reasoning `&lt;think&gt;` tags emitted by DeepSeek models and uses balanced-brace extraction to handle markdown codeblock wrappers.</a:t>
+                <a:spcPts val="250"/>
+              </a:spcAft>
+              <a:defRPr sz="1300">
+                <a:solidFill>
+                  <a:srgbClr val="F1F5F9"/>
+                </a:solidFill>
+                <a:latin typeface="Segoe UI"/>
+              </a:defRPr>
+            </a:pPr>
+            <a:r>
+              <a:t>• No Unbacked Knowledge: LLM relies *exclusively* on tool-returned observations.</a:t>
+            </a:r>
+          </a:p>
+          <a:p>
+            <a:pPr>
+              <a:spcAft>
+                <a:spcPts val="250"/>
+              </a:spcAft>
+              <a:defRPr sz="1300">
+                <a:solidFill>
+                  <a:srgbClr val="F1F5F9"/>
+                </a:solidFill>
+                <a:latin typeface="Segoe UI"/>
+              </a:defRPr>
+            </a:pPr>
+            <a:r>
+              <a:t>• Verbatim Source URL Binding: Observation objects must include explicit `source_url` pointing to real URLs returned during exploration.</a:t>
+            </a:r>
+          </a:p>
+          <a:p>
+            <a:pPr>
+              <a:spcAft>
+                <a:spcPts val="250"/>
+              </a:spcAft>
+              <a:defRPr sz="1300">
+                <a:solidFill>
+                  <a:srgbClr val="F1F5F9"/>
+                </a:solidFill>
+                <a:latin typeface="Segoe UI"/>
+              </a:defRPr>
+            </a:pPr>
+            <a:r>
+              <a:t>• Tolerant JSON Parsing (`llm_pool.py`): Strips reasoning `&lt;think&gt;` tags and uses balanced-brace extraction.</a:t>
             </a:r>
           </a:p>
         </p:txBody>
@@ -4243,7 +4275,7 @@
             <a:avLst/>
           </a:prstGeom>
           <a:solidFill>
-            <a:srgbClr val="0F172A"/>
+            <a:srgbClr val="090D16"/>
           </a:solidFill>
           <a:ln>
             <a:noFill/>
@@ -4279,8 +4311,8 @@
         </p:nvSpPr>
         <p:spPr>
           <a:xfrm>
-            <a:off x="731520" y="365760"/>
-            <a:ext cx="10728655" cy="822960"/>
+            <a:off x="548640" y="274320"/>
+            <a:ext cx="11094415" cy="685800"/>
           </a:xfrm>
           <a:prstGeom prst="rect">
             <a:avLst/>
@@ -4288,15 +4320,15 @@
           <a:noFill/>
         </p:spPr>
         <p:txBody>
-          <a:bodyPr wrap="square">
+          <a:bodyPr wrap="square" lIns="0" tIns="0" rIns="0" bIns="0">
             <a:spAutoFit/>
           </a:bodyPr>
           <a:lstStyle/>
           <a:p>
             <a:pPr>
-              <a:defRPr sz="2600" b="1">
-                <a:solidFill>
-                  <a:srgbClr val="818CF8"/>
+              <a:defRPr sz="2200" b="1">
+                <a:solidFill>
+                  <a:srgbClr val="38BDF8"/>
                 </a:solidFill>
                 <a:latin typeface="Segoe UI"/>
               </a:defRPr>
@@ -4315,14 +4347,14 @@
         </p:nvSpPr>
         <p:spPr>
           <a:xfrm>
-            <a:off x="731520" y="1188720"/>
-            <a:ext cx="10728655" cy="36576"/>
+            <a:off x="548640" y="1005840"/>
+            <a:ext cx="11094415" cy="27432"/>
           </a:xfrm>
           <a:prstGeom prst="rect">
             <a:avLst/>
           </a:prstGeom>
           <a:solidFill>
-            <a:srgbClr val="38BDF8"/>
+            <a:srgbClr val="0D9488"/>
           </a:solidFill>
           <a:ln>
             <a:noFill/>
@@ -4358,8 +4390,8 @@
         </p:nvSpPr>
         <p:spPr>
           <a:xfrm>
-            <a:off x="731520" y="1371600"/>
-            <a:ext cx="10728655" cy="4937760"/>
+            <a:off x="548640" y="1143000"/>
+            <a:ext cx="11094415" cy="5303520"/>
           </a:xfrm>
           <a:prstGeom prst="rect">
             <a:avLst/>
@@ -4367,48 +4399,48 @@
           <a:noFill/>
         </p:spPr>
         <p:txBody>
-          <a:bodyPr wrap="square">
+          <a:bodyPr wrap="square" lIns="0" tIns="0" rIns="0" bIns="0">
             <a:spAutoFit/>
           </a:bodyPr>
           <a:lstStyle/>
           <a:p>
             <a:pPr>
               <a:spcAft>
-                <a:spcPts val="800"/>
-              </a:spcAft>
-              <a:defRPr sz="2000" b="1">
-                <a:solidFill>
-                  <a:srgbClr val="94A3B8"/>
-                </a:solidFill>
-                <a:latin typeface="Segoe UI"/>
-              </a:defRPr>
-            </a:pPr>
-            <a:r>
-              <a:t>**Central Workflow Engine (`app/agent/report.py`)**</a:t>
-            </a:r>
-          </a:p>
-          <a:p>
-            <a:pPr>
-              <a:spcAft>
                 <a:spcPts val="400"/>
               </a:spcAft>
-              <a:defRPr sz="1400">
-                <a:solidFill>
-                  <a:srgbClr val="F1F5F9"/>
-                </a:solidFill>
-                <a:latin typeface="Segoe UI"/>
-              </a:defRPr>
-            </a:pPr>
-            <a:r>
-              <a:t>• Function: `generate_report(company, url)` orchestrates the end-to-end multi-phase report synthesis process.</a:t>
-            </a:r>
-          </a:p>
-          <a:p>
-            <a:pPr>
-              <a:spcAft>
-                <a:spcPts val="400"/>
-              </a:spcAft>
-              <a:defRPr sz="1400">
+              <a:defRPr sz="1700" b="1">
+                <a:solidFill>
+                  <a:srgbClr val="2DD4BF"/>
+                </a:solidFill>
+                <a:latin typeface="Segoe UI"/>
+              </a:defRPr>
+            </a:pPr>
+            <a:r>
+              <a:t>Central Workflow Engine (`app/agent/report.py`)</a:t>
+            </a:r>
+          </a:p>
+          <a:p>
+            <a:pPr>
+              <a:spcAft>
+                <a:spcPts val="250"/>
+              </a:spcAft>
+              <a:defRPr sz="1300">
+                <a:solidFill>
+                  <a:srgbClr val="F1F5F9"/>
+                </a:solidFill>
+                <a:latin typeface="Segoe UI"/>
+              </a:defRPr>
+            </a:pPr>
+            <a:r>
+              <a:t>• Function: `generate_report(company, url)` orchestrates the multi-phase synthesis process.</a:t>
+            </a:r>
+          </a:p>
+          <a:p>
+            <a:pPr>
+              <a:spcAft>
+                <a:spcPts val="250"/>
+              </a:spcAft>
+              <a:defRPr sz="1300">
                 <a:solidFill>
                   <a:srgbClr val="F1F5F9"/>
                 </a:solidFill>
@@ -4422,9 +4454,9 @@
           <a:p>
             <a:pPr>
               <a:spcAft>
-                <a:spcPts val="400"/>
-              </a:spcAft>
-              <a:defRPr sz="1400">
+                <a:spcPts val="250"/>
+              </a:spcAft>
+              <a:defRPr sz="1300">
                 <a:solidFill>
                   <a:srgbClr val="F1F5F9"/>
                 </a:solidFill>
@@ -4438,57 +4470,57 @@
           <a:p>
             <a:pPr>
               <a:spcAft>
-                <a:spcPts val="400"/>
-              </a:spcAft>
-              <a:defRPr sz="1400">
-                <a:solidFill>
-                  <a:srgbClr val="F1F5F9"/>
-                </a:solidFill>
-                <a:latin typeface="Segoe UI"/>
-              </a:defRPr>
-            </a:pPr>
-            <a:r>
-              <a:t>2. Phase B (Parallel Persona Panel): Invokes `run_persona_panel()` to evaluate shared evidence across 3 reviewer perspectives.</a:t>
-            </a:r>
-          </a:p>
-          <a:p>
-            <a:pPr>
-              <a:spcAft>
-                <a:spcPts val="400"/>
-              </a:spcAft>
-              <a:defRPr sz="1400">
-                <a:solidFill>
-                  <a:srgbClr val="F1F5F9"/>
-                </a:solidFill>
-                <a:latin typeface="Segoe UI"/>
-              </a:defRPr>
-            </a:pPr>
-            <a:r>
-              <a:t>3. Phase C (Report Synthesis): Calls LLM pool with combined exploration state + persona outputs to build draft `FirstImpressionReport`.</a:t>
-            </a:r>
-          </a:p>
-          <a:p>
-            <a:pPr>
-              <a:spcAft>
-                <a:spcPts val="400"/>
-              </a:spcAft>
-              <a:defRPr sz="1400">
-                <a:solidFill>
-                  <a:srgbClr val="F1F5F9"/>
-                </a:solidFill>
-                <a:latin typeface="Segoe UI"/>
-              </a:defRPr>
-            </a:pPr>
-            <a:r>
-              <a:t>4. Phase D (5-Layer Guard Stack): Executes schema validation, citation URL checking, LLM fact-check judge pass, and scope caveat enforcement.</a:t>
-            </a:r>
-          </a:p>
-          <a:p>
-            <a:pPr>
-              <a:spcAft>
-                <a:spcPts val="400"/>
-              </a:spcAft>
-              <a:defRPr sz="1400">
+                <a:spcPts val="250"/>
+              </a:spcAft>
+              <a:defRPr sz="1300">
+                <a:solidFill>
+                  <a:srgbClr val="F1F5F9"/>
+                </a:solidFill>
+                <a:latin typeface="Segoe UI"/>
+              </a:defRPr>
+            </a:pPr>
+            <a:r>
+              <a:t>2. Phase B (Parallel Persona Panel): Invokes `run_persona_panel()` to evaluate evidence across 3 perspectives.</a:t>
+            </a:r>
+          </a:p>
+          <a:p>
+            <a:pPr>
+              <a:spcAft>
+                <a:spcPts val="250"/>
+              </a:spcAft>
+              <a:defRPr sz="1300">
+                <a:solidFill>
+                  <a:srgbClr val="F1F5F9"/>
+                </a:solidFill>
+                <a:latin typeface="Segoe UI"/>
+              </a:defRPr>
+            </a:pPr>
+            <a:r>
+              <a:t>3. Phase C (Report Synthesis): Calls LLM pool with evidence + persona outputs to build draft report.</a:t>
+            </a:r>
+          </a:p>
+          <a:p>
+            <a:pPr>
+              <a:spcAft>
+                <a:spcPts val="250"/>
+              </a:spcAft>
+              <a:defRPr sz="1300">
+                <a:solidFill>
+                  <a:srgbClr val="F1F5F9"/>
+                </a:solidFill>
+                <a:latin typeface="Segoe UI"/>
+              </a:defRPr>
+            </a:pPr>
+            <a:r>
+              <a:t>4. Phase D (5-Layer Guard Stack): Executes schema validation, citation check, LLM fact-check judge pass, and scope caveat enforcement.</a:t>
+            </a:r>
+          </a:p>
+          <a:p>
+            <a:pPr>
+              <a:spcAft>
+                <a:spcPts val="250"/>
+              </a:spcAft>
+              <a:defRPr sz="1300">
                 <a:solidFill>
                   <a:srgbClr val="F1F5F9"/>
                 </a:solidFill>
@@ -4534,7 +4566,7 @@
             <a:avLst/>
           </a:prstGeom>
           <a:solidFill>
-            <a:srgbClr val="0F172A"/>
+            <a:srgbClr val="090D16"/>
           </a:solidFill>
           <a:ln>
             <a:noFill/>
@@ -4570,8 +4602,8 @@
         </p:nvSpPr>
         <p:spPr>
           <a:xfrm>
-            <a:off x="731520" y="365760"/>
-            <a:ext cx="10728655" cy="822960"/>
+            <a:off x="548640" y="274320"/>
+            <a:ext cx="11094415" cy="685800"/>
           </a:xfrm>
           <a:prstGeom prst="rect">
             <a:avLst/>
@@ -4579,15 +4611,15 @@
           <a:noFill/>
         </p:spPr>
         <p:txBody>
-          <a:bodyPr wrap="square">
+          <a:bodyPr wrap="square" lIns="0" tIns="0" rIns="0" bIns="0">
             <a:spAutoFit/>
           </a:bodyPr>
           <a:lstStyle/>
           <a:p>
             <a:pPr>
-              <a:defRPr sz="2600" b="1">
-                <a:solidFill>
-                  <a:srgbClr val="818CF8"/>
+              <a:defRPr sz="2200" b="1">
+                <a:solidFill>
+                  <a:srgbClr val="38BDF8"/>
                 </a:solidFill>
                 <a:latin typeface="Segoe UI"/>
               </a:defRPr>
@@ -4606,14 +4638,14 @@
         </p:nvSpPr>
         <p:spPr>
           <a:xfrm>
-            <a:off x="731520" y="1188720"/>
-            <a:ext cx="10728655" cy="36576"/>
+            <a:off x="548640" y="1005840"/>
+            <a:ext cx="11094415" cy="27432"/>
           </a:xfrm>
           <a:prstGeom prst="rect">
             <a:avLst/>
           </a:prstGeom>
           <a:solidFill>
-            <a:srgbClr val="38BDF8"/>
+            <a:srgbClr val="0D9488"/>
           </a:solidFill>
           <a:ln>
             <a:noFill/>
@@ -4649,8 +4681,8 @@
         </p:nvSpPr>
         <p:spPr>
           <a:xfrm>
-            <a:off x="731520" y="1371600"/>
-            <a:ext cx="10728655" cy="4937760"/>
+            <a:off x="548640" y="1143000"/>
+            <a:ext cx="11094415" cy="5303520"/>
           </a:xfrm>
           <a:prstGeom prst="rect">
             <a:avLst/>
@@ -4658,32 +4690,32 @@
           <a:noFill/>
         </p:spPr>
         <p:txBody>
-          <a:bodyPr wrap="square">
+          <a:bodyPr wrap="square" lIns="0" tIns="0" rIns="0" bIns="0">
             <a:spAutoFit/>
           </a:bodyPr>
           <a:lstStyle/>
           <a:p>
             <a:pPr>
               <a:spcAft>
-                <a:spcPts val="800"/>
-              </a:spcAft>
-              <a:defRPr sz="2000" b="1">
-                <a:solidFill>
-                  <a:srgbClr val="94A3B8"/>
-                </a:solidFill>
-                <a:latin typeface="Segoe UI"/>
-              </a:defRPr>
-            </a:pPr>
-            <a:r>
-              <a:t>**Parallel Perspective Evaluation (`app/agent/personas.py` &amp; `panel.py`)**</a:t>
-            </a:r>
-          </a:p>
-          <a:p>
-            <a:pPr>
-              <a:spcAft>
                 <a:spcPts val="400"/>
               </a:spcAft>
-              <a:defRPr sz="1400">
+              <a:defRPr sz="1700" b="1">
+                <a:solidFill>
+                  <a:srgbClr val="2DD4BF"/>
+                </a:solidFill>
+                <a:latin typeface="Segoe UI"/>
+              </a:defRPr>
+            </a:pPr>
+            <a:r>
+              <a:t>Parallel Perspective Evaluation (`app/agent/personas.py` &amp; `panel.py`)</a:t>
+            </a:r>
+          </a:p>
+          <a:p>
+            <a:pPr>
+              <a:spcAft>
+                <a:spcPts val="250"/>
+              </a:spcAft>
+              <a:defRPr sz="1300">
                 <a:solidFill>
                   <a:srgbClr val="F1F5F9"/>
                 </a:solidFill>
@@ -4697,9 +4729,9 @@
           <a:p>
             <a:pPr>
               <a:spcAft>
-                <a:spcPts val="400"/>
-              </a:spcAft>
-              <a:defRPr sz="1400">
+                <a:spcPts val="250"/>
+              </a:spcAft>
+              <a:defRPr sz="1300">
                 <a:solidFill>
                   <a:srgbClr val="F1F5F9"/>
                 </a:solidFill>
@@ -4713,9 +4745,9 @@
           <a:p>
             <a:pPr>
               <a:spcAft>
-                <a:spcPts val="400"/>
-              </a:spcAft>
-              <a:defRPr sz="1400">
+                <a:spcPts val="250"/>
+              </a:spcAft>
+              <a:defRPr sz="1300">
                 <a:solidFill>
                   <a:srgbClr val="F1F5F9"/>
                 </a:solidFill>
@@ -4729,9 +4761,9 @@
           <a:p>
             <a:pPr>
               <a:spcAft>
-                <a:spcPts val="400"/>
-              </a:spcAft>
-              <a:defRPr sz="1400">
+                <a:spcPts val="250"/>
+              </a:spcAft>
+              <a:defRPr sz="1300">
                 <a:solidFill>
                   <a:srgbClr val="F1F5F9"/>
                 </a:solidFill>
@@ -4745,9 +4777,9 @@
           <a:p>
             <a:pPr>
               <a:spcAft>
-                <a:spcPts val="400"/>
-              </a:spcAft>
-              <a:defRPr sz="1400">
+                <a:spcPts val="250"/>
+              </a:spcAft>
+              <a:defRPr sz="1300">
                 <a:solidFill>
                   <a:srgbClr val="F1F5F9"/>
                 </a:solidFill>
@@ -4761,17 +4793,17 @@
           <a:p>
             <a:pPr>
               <a:spcAft>
-                <a:spcPts val="400"/>
-              </a:spcAft>
-              <a:defRPr sz="1400">
-                <a:solidFill>
-                  <a:srgbClr val="F1F5F9"/>
-                </a:solidFill>
-                <a:latin typeface="Segoe UI"/>
-              </a:defRPr>
-            </a:pPr>
-            <a:r>
-              <a:t>• Parallel Fan-Out: Runs persona prompts in parallel over shared evidence base, storing impressions into a unified panel verdict dictionary.</a:t>
+                <a:spcPts val="250"/>
+              </a:spcAft>
+              <a:defRPr sz="1300">
+                <a:solidFill>
+                  <a:srgbClr val="F1F5F9"/>
+                </a:solidFill>
+                <a:latin typeface="Segoe UI"/>
+              </a:defRPr>
+            </a:pPr>
+            <a:r>
+              <a:t>• Parallel Fan-Out: Runs persona prompts in parallel over shared evidence base.</a:t>
             </a:r>
           </a:p>
         </p:txBody>
@@ -4809,7 +4841,7 @@
             <a:avLst/>
           </a:prstGeom>
           <a:solidFill>
-            <a:srgbClr val="0F172A"/>
+            <a:srgbClr val="090D16"/>
           </a:solidFill>
           <a:ln>
             <a:noFill/>
@@ -4845,8 +4877,8 @@
         </p:nvSpPr>
         <p:spPr>
           <a:xfrm>
-            <a:off x="731520" y="365760"/>
-            <a:ext cx="10728655" cy="822960"/>
+            <a:off x="548640" y="274320"/>
+            <a:ext cx="11094415" cy="685800"/>
           </a:xfrm>
           <a:prstGeom prst="rect">
             <a:avLst/>
@@ -4854,15 +4886,15 @@
           <a:noFill/>
         </p:spPr>
         <p:txBody>
-          <a:bodyPr wrap="square">
+          <a:bodyPr wrap="square" lIns="0" tIns="0" rIns="0" bIns="0">
             <a:spAutoFit/>
           </a:bodyPr>
           <a:lstStyle/>
           <a:p>
             <a:pPr>
-              <a:defRPr sz="2600" b="1">
-                <a:solidFill>
-                  <a:srgbClr val="818CF8"/>
+              <a:defRPr sz="2200" b="1">
+                <a:solidFill>
+                  <a:srgbClr val="38BDF8"/>
                 </a:solidFill>
                 <a:latin typeface="Segoe UI"/>
               </a:defRPr>
@@ -4881,14 +4913,14 @@
         </p:nvSpPr>
         <p:spPr>
           <a:xfrm>
-            <a:off x="731520" y="1188720"/>
-            <a:ext cx="10728655" cy="36576"/>
+            <a:off x="548640" y="1005840"/>
+            <a:ext cx="11094415" cy="27432"/>
           </a:xfrm>
           <a:prstGeom prst="rect">
             <a:avLst/>
           </a:prstGeom>
           <a:solidFill>
-            <a:srgbClr val="38BDF8"/>
+            <a:srgbClr val="0D9488"/>
           </a:solidFill>
           <a:ln>
             <a:noFill/>
@@ -4924,8 +4956,8 @@
         </p:nvSpPr>
         <p:spPr>
           <a:xfrm>
-            <a:off x="731520" y="1371600"/>
-            <a:ext cx="5120640" cy="4937760"/>
+            <a:off x="548640" y="1143000"/>
+            <a:ext cx="5120640" cy="5303520"/>
           </a:xfrm>
           <a:prstGeom prst="rect">
             <a:avLst/>
@@ -4933,24 +4965,24 @@
           <a:noFill/>
         </p:spPr>
         <p:txBody>
-          <a:bodyPr wrap="square">
+          <a:bodyPr wrap="square" lIns="0" tIns="0" rIns="0" bIns="0">
             <a:spAutoFit/>
           </a:bodyPr>
           <a:lstStyle/>
           <a:p>
             <a:pPr>
               <a:spcAft>
-                <a:spcPts val="800"/>
-              </a:spcAft>
-              <a:defRPr sz="2000" b="1">
-                <a:solidFill>
-                  <a:srgbClr val="94A3B8"/>
-                </a:solidFill>
-                <a:latin typeface="Segoe UI"/>
-              </a:defRPr>
-            </a:pPr>
-            <a:r>
-              <a:t>**5-Layer Trust &amp; Verification Pipeline**</a:t>
+                <a:spcPts val="400"/>
+              </a:spcAft>
+              <a:defRPr sz="1600" b="1">
+                <a:solidFill>
+                  <a:srgbClr val="2DD4BF"/>
+                </a:solidFill>
+                <a:latin typeface="Segoe UI"/>
+              </a:defRPr>
+            </a:pPr>
+            <a:r>
+              <a:t>5-Layer Trust &amp; Verification Pipeline</a:t>
             </a:r>
           </a:p>
         </p:txBody>
@@ -4963,18 +4995,18 @@
         </p:nvSpPr>
         <p:spPr>
           <a:xfrm>
-            <a:off x="6035040" y="1371600"/>
-            <a:ext cx="5394960" cy="4937760"/>
+            <a:off x="5852160" y="1143000"/>
+            <a:ext cx="5760720" cy="5303520"/>
           </a:xfrm>
           <a:prstGeom prst="roundRect">
             <a:avLst/>
           </a:prstGeom>
           <a:solidFill>
-            <a:srgbClr val="1E293B"/>
+            <a:srgbClr val="0F172A"/>
           </a:solidFill>
           <a:ln>
             <a:solidFill>
-              <a:srgbClr val="38BDF8"/>
+              <a:srgbClr val="0D9488"/>
             </a:solidFill>
           </a:ln>
         </p:spPr>
@@ -5008,8 +5040,8 @@
         </p:nvSpPr>
         <p:spPr>
           <a:xfrm>
-            <a:off x="6217920" y="1463040"/>
-            <a:ext cx="5029200" cy="4754880"/>
+            <a:off x="5989320" y="1234440"/>
+            <a:ext cx="5486400" cy="5120640"/>
           </a:xfrm>
           <a:prstGeom prst="rect">
             <a:avLst/>
@@ -5017,13 +5049,13 @@
           <a:noFill/>
         </p:spPr>
         <p:txBody>
-          <a:bodyPr wrap="square">
+          <a:bodyPr wrap="square" lIns="0" tIns="0" rIns="0" bIns="0">
             <a:spAutoFit/>
           </a:bodyPr>
           <a:lstStyle/>
           <a:p>
             <a:pPr>
-              <a:defRPr sz="1100">
+              <a:defRPr sz="850">
                 <a:solidFill>
                   <a:srgbClr val="E2E8F0"/>
                 </a:solidFill>
@@ -5197,7 +5229,7 @@
             <a:avLst/>
           </a:prstGeom>
           <a:solidFill>
-            <a:srgbClr val="0F172A"/>
+            <a:srgbClr val="090D16"/>
           </a:solidFill>
           <a:ln>
             <a:noFill/>
@@ -5233,8 +5265,8 @@
         </p:nvSpPr>
         <p:spPr>
           <a:xfrm>
-            <a:off x="731520" y="365760"/>
-            <a:ext cx="10728655" cy="822960"/>
+            <a:off x="548640" y="274320"/>
+            <a:ext cx="11094415" cy="685800"/>
           </a:xfrm>
           <a:prstGeom prst="rect">
             <a:avLst/>
@@ -5242,15 +5274,15 @@
           <a:noFill/>
         </p:spPr>
         <p:txBody>
-          <a:bodyPr wrap="square">
+          <a:bodyPr wrap="square" lIns="0" tIns="0" rIns="0" bIns="0">
             <a:spAutoFit/>
           </a:bodyPr>
           <a:lstStyle/>
           <a:p>
             <a:pPr>
-              <a:defRPr sz="2600" b="1">
-                <a:solidFill>
-                  <a:srgbClr val="818CF8"/>
+              <a:defRPr sz="2200" b="1">
+                <a:solidFill>
+                  <a:srgbClr val="38BDF8"/>
                 </a:solidFill>
                 <a:latin typeface="Segoe UI"/>
               </a:defRPr>
@@ -5269,14 +5301,14 @@
         </p:nvSpPr>
         <p:spPr>
           <a:xfrm>
-            <a:off x="731520" y="1188720"/>
-            <a:ext cx="10728655" cy="36576"/>
+            <a:off x="548640" y="1005840"/>
+            <a:ext cx="11094415" cy="27432"/>
           </a:xfrm>
           <a:prstGeom prst="rect">
             <a:avLst/>
           </a:prstGeom>
           <a:solidFill>
-            <a:srgbClr val="38BDF8"/>
+            <a:srgbClr val="0D9488"/>
           </a:solidFill>
           <a:ln>
             <a:noFill/>
@@ -5312,8 +5344,8 @@
         </p:nvSpPr>
         <p:spPr>
           <a:xfrm>
-            <a:off x="731520" y="1371600"/>
-            <a:ext cx="5120640" cy="4937760"/>
+            <a:off x="548640" y="1143000"/>
+            <a:ext cx="5120640" cy="5303520"/>
           </a:xfrm>
           <a:prstGeom prst="rect">
             <a:avLst/>
@@ -5321,24 +5353,24 @@
           <a:noFill/>
         </p:spPr>
         <p:txBody>
-          <a:bodyPr wrap="square">
+          <a:bodyPr wrap="square" lIns="0" tIns="0" rIns="0" bIns="0">
             <a:spAutoFit/>
           </a:bodyPr>
           <a:lstStyle/>
           <a:p>
             <a:pPr>
               <a:spcAft>
-                <a:spcPts val="800"/>
-              </a:spcAft>
-              <a:defRPr sz="2000" b="1">
-                <a:solidFill>
-                  <a:srgbClr val="94A3B8"/>
-                </a:solidFill>
-                <a:latin typeface="Segoe UI"/>
-              </a:defRPr>
-            </a:pPr>
-            <a:r>
-              <a:t>**Resilient NVIDIA NIM Pool &amp; Circuit Breakers (`app/agent/llm_pool.py`)**</a:t>
+                <a:spcPts val="400"/>
+              </a:spcAft>
+              <a:defRPr sz="1600" b="1">
+                <a:solidFill>
+                  <a:srgbClr val="2DD4BF"/>
+                </a:solidFill>
+                <a:latin typeface="Segoe UI"/>
+              </a:defRPr>
+            </a:pPr>
+            <a:r>
+              <a:t>Resilient NVIDIA NIM Pool &amp; Circuit Breakers (`app/agent/llm_pool.py`)</a:t>
             </a:r>
           </a:p>
         </p:txBody>
@@ -5351,18 +5383,18 @@
         </p:nvSpPr>
         <p:spPr>
           <a:xfrm>
-            <a:off x="6035040" y="1371600"/>
-            <a:ext cx="5394960" cy="4937760"/>
+            <a:off x="5852160" y="1143000"/>
+            <a:ext cx="5760720" cy="5303520"/>
           </a:xfrm>
           <a:prstGeom prst="roundRect">
             <a:avLst/>
           </a:prstGeom>
           <a:solidFill>
-            <a:srgbClr val="1E293B"/>
+            <a:srgbClr val="0F172A"/>
           </a:solidFill>
           <a:ln>
             <a:solidFill>
-              <a:srgbClr val="38BDF8"/>
+              <a:srgbClr val="0D9488"/>
             </a:solidFill>
           </a:ln>
         </p:spPr>
@@ -5396,8 +5428,8 @@
         </p:nvSpPr>
         <p:spPr>
           <a:xfrm>
-            <a:off x="6217920" y="1463040"/>
-            <a:ext cx="5029200" cy="4754880"/>
+            <a:off x="5989320" y="1234440"/>
+            <a:ext cx="5486400" cy="5120640"/>
           </a:xfrm>
           <a:prstGeom prst="rect">
             <a:avLst/>
@@ -5405,13 +5437,13 @@
           <a:noFill/>
         </p:spPr>
         <p:txBody>
-          <a:bodyPr wrap="square">
+          <a:bodyPr wrap="square" lIns="0" tIns="0" rIns="0" bIns="0">
             <a:spAutoFit/>
           </a:bodyPr>
           <a:lstStyle/>
           <a:p>
             <a:pPr>
-              <a:defRPr sz="1100">
+              <a:defRPr sz="950">
                 <a:solidFill>
                   <a:srgbClr val="E2E8F0"/>
                 </a:solidFill>
@@ -5497,7 +5529,7 @@
             <a:avLst/>
           </a:prstGeom>
           <a:solidFill>
-            <a:srgbClr val="0F172A"/>
+            <a:srgbClr val="090D16"/>
           </a:solidFill>
           <a:ln>
             <a:noFill/>
@@ -5533,8 +5565,8 @@
         </p:nvSpPr>
         <p:spPr>
           <a:xfrm>
-            <a:off x="731520" y="365760"/>
-            <a:ext cx="10728655" cy="822960"/>
+            <a:off x="548640" y="274320"/>
+            <a:ext cx="11094415" cy="685800"/>
           </a:xfrm>
           <a:prstGeom prst="rect">
             <a:avLst/>
@@ -5542,15 +5574,15 @@
           <a:noFill/>
         </p:spPr>
         <p:txBody>
-          <a:bodyPr wrap="square">
+          <a:bodyPr wrap="square" lIns="0" tIns="0" rIns="0" bIns="0">
             <a:spAutoFit/>
           </a:bodyPr>
           <a:lstStyle/>
           <a:p>
             <a:pPr>
-              <a:defRPr sz="2600" b="1">
-                <a:solidFill>
-                  <a:srgbClr val="818CF8"/>
+              <a:defRPr sz="2200" b="1">
+                <a:solidFill>
+                  <a:srgbClr val="38BDF8"/>
                 </a:solidFill>
                 <a:latin typeface="Segoe UI"/>
               </a:defRPr>
@@ -5569,14 +5601,14 @@
         </p:nvSpPr>
         <p:spPr>
           <a:xfrm>
-            <a:off x="731520" y="1188720"/>
-            <a:ext cx="10728655" cy="36576"/>
+            <a:off x="548640" y="1005840"/>
+            <a:ext cx="11094415" cy="27432"/>
           </a:xfrm>
           <a:prstGeom prst="rect">
             <a:avLst/>
           </a:prstGeom>
           <a:solidFill>
-            <a:srgbClr val="38BDF8"/>
+            <a:srgbClr val="0D9488"/>
           </a:solidFill>
           <a:ln>
             <a:noFill/>
@@ -5612,8 +5644,8 @@
         </p:nvSpPr>
         <p:spPr>
           <a:xfrm>
-            <a:off x="731520" y="1371600"/>
-            <a:ext cx="10728655" cy="4937760"/>
+            <a:off x="548640" y="1143000"/>
+            <a:ext cx="11094415" cy="5303520"/>
           </a:xfrm>
           <a:prstGeom prst="rect">
             <a:avLst/>
@@ -5621,32 +5653,32 @@
           <a:noFill/>
         </p:spPr>
         <p:txBody>
-          <a:bodyPr wrap="square">
+          <a:bodyPr wrap="square" lIns="0" tIns="0" rIns="0" bIns="0">
             <a:spAutoFit/>
           </a:bodyPr>
           <a:lstStyle/>
           <a:p>
             <a:pPr>
               <a:spcAft>
-                <a:spcPts val="800"/>
-              </a:spcAft>
-              <a:defRPr sz="2000" b="1">
-                <a:solidFill>
-                  <a:srgbClr val="94A3B8"/>
-                </a:solidFill>
-                <a:latin typeface="Segoe UI"/>
-              </a:defRPr>
-            </a:pPr>
-            <a:r>
-              <a:t>**Rigorous Benchmarking &amp; Quality Assurance (`evals/`)**</a:t>
-            </a:r>
-          </a:p>
-          <a:p>
-            <a:pPr>
-              <a:spcAft>
                 <a:spcPts val="400"/>
               </a:spcAft>
-              <a:defRPr sz="1400">
+              <a:defRPr sz="1700" b="1">
+                <a:solidFill>
+                  <a:srgbClr val="2DD4BF"/>
+                </a:solidFill>
+                <a:latin typeface="Segoe UI"/>
+              </a:defRPr>
+            </a:pPr>
+            <a:r>
+              <a:t>Rigorous Benchmarking &amp; Quality Assurance (`evals/`)</a:t>
+            </a:r>
+          </a:p>
+          <a:p>
+            <a:pPr>
+              <a:spcAft>
+                <a:spcPts val="250"/>
+              </a:spcAft>
+              <a:defRPr sz="1300">
                 <a:solidFill>
                   <a:srgbClr val="F1F5F9"/>
                 </a:solidFill>
@@ -5660,9 +5692,9 @@
           <a:p>
             <a:pPr>
               <a:spcAft>
-                <a:spcPts val="400"/>
-              </a:spcAft>
-              <a:defRPr sz="1400">
+                <a:spcPts val="250"/>
+              </a:spcAft>
+              <a:defRPr sz="1300">
                 <a:solidFill>
                   <a:srgbClr val="F1F5F9"/>
                 </a:solidFill>
@@ -5676,9 +5708,9 @@
           <a:p>
             <a:pPr>
               <a:spcAft>
-                <a:spcPts val="400"/>
-              </a:spcAft>
-              <a:defRPr sz="1400">
+                <a:spcPts val="250"/>
+              </a:spcAft>
+              <a:defRPr sz="1300">
                 <a:solidFill>
                   <a:srgbClr val="F1F5F9"/>
                 </a:solidFill>
@@ -5692,9 +5724,9 @@
           <a:p>
             <a:pPr>
               <a:spcAft>
-                <a:spcPts val="400"/>
-              </a:spcAft>
-              <a:defRPr sz="1400">
+                <a:spcPts val="250"/>
+              </a:spcAft>
+              <a:defRPr sz="1300">
                 <a:solidFill>
                   <a:srgbClr val="F1F5F9"/>
                 </a:solidFill>
@@ -5708,9 +5740,9 @@
           <a:p>
             <a:pPr>
               <a:spcAft>
-                <a:spcPts val="400"/>
-              </a:spcAft>
-              <a:defRPr sz="1400">
+                <a:spcPts val="250"/>
+              </a:spcAft>
+              <a:defRPr sz="1300">
                 <a:solidFill>
                   <a:srgbClr val="F1F5F9"/>
                 </a:solidFill>
@@ -5724,9 +5756,9 @@
           <a:p>
             <a:pPr>
               <a:spcAft>
-                <a:spcPts val="400"/>
-              </a:spcAft>
-              <a:defRPr sz="1400">
+                <a:spcPts val="250"/>
+              </a:spcAft>
+              <a:defRPr sz="1300">
                 <a:solidFill>
                   <a:srgbClr val="F1F5F9"/>
                 </a:solidFill>
@@ -5772,7 +5804,7 @@
             <a:avLst/>
           </a:prstGeom>
           <a:solidFill>
-            <a:srgbClr val="0F172A"/>
+            <a:srgbClr val="090D16"/>
           </a:solidFill>
           <a:ln>
             <a:noFill/>
@@ -5808,8 +5840,8 @@
         </p:nvSpPr>
         <p:spPr>
           <a:xfrm>
-            <a:off x="731520" y="365760"/>
-            <a:ext cx="10728655" cy="822960"/>
+            <a:off x="548640" y="274320"/>
+            <a:ext cx="11094415" cy="685800"/>
           </a:xfrm>
           <a:prstGeom prst="rect">
             <a:avLst/>
@@ -5817,15 +5849,15 @@
           <a:noFill/>
         </p:spPr>
         <p:txBody>
-          <a:bodyPr wrap="square">
+          <a:bodyPr wrap="square" lIns="0" tIns="0" rIns="0" bIns="0">
             <a:spAutoFit/>
           </a:bodyPr>
           <a:lstStyle/>
           <a:p>
             <a:pPr>
-              <a:defRPr sz="2600" b="1">
-                <a:solidFill>
-                  <a:srgbClr val="818CF8"/>
+              <a:defRPr sz="2200" b="1">
+                <a:solidFill>
+                  <a:srgbClr val="38BDF8"/>
                 </a:solidFill>
                 <a:latin typeface="Segoe UI"/>
               </a:defRPr>
@@ -5844,14 +5876,14 @@
         </p:nvSpPr>
         <p:spPr>
           <a:xfrm>
-            <a:off x="731520" y="1188720"/>
-            <a:ext cx="10728655" cy="36576"/>
+            <a:off x="548640" y="1005840"/>
+            <a:ext cx="11094415" cy="27432"/>
           </a:xfrm>
           <a:prstGeom prst="rect">
             <a:avLst/>
           </a:prstGeom>
           <a:solidFill>
-            <a:srgbClr val="38BDF8"/>
+            <a:srgbClr val="0D9488"/>
           </a:solidFill>
           <a:ln>
             <a:noFill/>
@@ -5887,8 +5919,8 @@
         </p:nvSpPr>
         <p:spPr>
           <a:xfrm>
-            <a:off x="731520" y="1371600"/>
-            <a:ext cx="10728655" cy="4937760"/>
+            <a:off x="548640" y="1143000"/>
+            <a:ext cx="11094415" cy="5303520"/>
           </a:xfrm>
           <a:prstGeom prst="rect">
             <a:avLst/>
@@ -5896,32 +5928,32 @@
           <a:noFill/>
         </p:spPr>
         <p:txBody>
-          <a:bodyPr wrap="square">
+          <a:bodyPr wrap="square" lIns="0" tIns="0" rIns="0" bIns="0">
             <a:spAutoFit/>
           </a:bodyPr>
           <a:lstStyle/>
           <a:p>
             <a:pPr>
               <a:spcAft>
-                <a:spcPts val="800"/>
-              </a:spcAft>
-              <a:defRPr sz="2000" b="1">
-                <a:solidFill>
-                  <a:srgbClr val="94A3B8"/>
-                </a:solidFill>
-                <a:latin typeface="Segoe UI"/>
-              </a:defRPr>
-            </a:pPr>
-            <a:r>
-              <a:t>**RAG Search Benchmark Performance (`evals/run_retrieval_eval.py`)**</a:t>
-            </a:r>
-          </a:p>
-          <a:p>
-            <a:pPr>
-              <a:spcAft>
                 <a:spcPts val="400"/>
               </a:spcAft>
-              <a:defRPr sz="1400">
+              <a:defRPr sz="1700" b="1">
+                <a:solidFill>
+                  <a:srgbClr val="2DD4BF"/>
+                </a:solidFill>
+                <a:latin typeface="Segoe UI"/>
+              </a:defRPr>
+            </a:pPr>
+            <a:r>
+              <a:t>RAG Search Benchmark Performance (`evals/run_retrieval_eval.py`)</a:t>
+            </a:r>
+          </a:p>
+          <a:p>
+            <a:pPr>
+              <a:spcAft>
+                <a:spcPts val="250"/>
+              </a:spcAft>
+              <a:defRPr sz="1300">
                 <a:solidFill>
                   <a:srgbClr val="F1F5F9"/>
                 </a:solidFill>
@@ -5935,9 +5967,9 @@
           <a:p>
             <a:pPr>
               <a:spcAft>
-                <a:spcPts val="400"/>
-              </a:spcAft>
-              <a:defRPr sz="1400">
+                <a:spcPts val="250"/>
+              </a:spcAft>
+              <a:defRPr sz="1300">
                 <a:solidFill>
                   <a:srgbClr val="F1F5F9"/>
                 </a:solidFill>
@@ -5951,9 +5983,9 @@
           <a:p>
             <a:pPr>
               <a:spcAft>
-                <a:spcPts val="400"/>
-              </a:spcAft>
-              <a:defRPr sz="1400">
+                <a:spcPts val="250"/>
+              </a:spcAft>
+              <a:defRPr sz="1300">
                 <a:solidFill>
                   <a:srgbClr val="F1F5F9"/>
                 </a:solidFill>
@@ -5967,9 +5999,9 @@
           <a:p>
             <a:pPr>
               <a:spcAft>
-                <a:spcPts val="400"/>
-              </a:spcAft>
-              <a:defRPr sz="1400">
+                <a:spcPts val="250"/>
+              </a:spcAft>
+              <a:defRPr sz="1300">
                 <a:solidFill>
                   <a:srgbClr val="F1F5F9"/>
                 </a:solidFill>
@@ -5983,9 +6015,9 @@
           <a:p>
             <a:pPr>
               <a:spcAft>
-                <a:spcPts val="400"/>
-              </a:spcAft>
-              <a:defRPr sz="1400">
+                <a:spcPts val="250"/>
+              </a:spcAft>
+              <a:defRPr sz="1300">
                 <a:solidFill>
                   <a:srgbClr val="F1F5F9"/>
                 </a:solidFill>
@@ -5999,9 +6031,9 @@
           <a:p>
             <a:pPr>
               <a:spcAft>
-                <a:spcPts val="400"/>
-              </a:spcAft>
-              <a:defRPr sz="1400">
+                <a:spcPts val="250"/>
+              </a:spcAft>
+              <a:defRPr sz="1300">
                 <a:solidFill>
                   <a:srgbClr val="F1F5F9"/>
                 </a:solidFill>
@@ -6047,7 +6079,7 @@
             <a:avLst/>
           </a:prstGeom>
           <a:solidFill>
-            <a:srgbClr val="0F172A"/>
+            <a:srgbClr val="090D16"/>
           </a:solidFill>
           <a:ln>
             <a:noFill/>
@@ -6083,8 +6115,8 @@
         </p:nvSpPr>
         <p:spPr>
           <a:xfrm>
-            <a:off x="731520" y="365760"/>
-            <a:ext cx="10728655" cy="822960"/>
+            <a:off x="548640" y="274320"/>
+            <a:ext cx="11094415" cy="685800"/>
           </a:xfrm>
           <a:prstGeom prst="rect">
             <a:avLst/>
@@ -6092,15 +6124,15 @@
           <a:noFill/>
         </p:spPr>
         <p:txBody>
-          <a:bodyPr wrap="square">
+          <a:bodyPr wrap="square" lIns="0" tIns="0" rIns="0" bIns="0">
             <a:spAutoFit/>
           </a:bodyPr>
           <a:lstStyle/>
           <a:p>
             <a:pPr>
-              <a:defRPr sz="2600" b="1">
-                <a:solidFill>
-                  <a:srgbClr val="818CF8"/>
+              <a:defRPr sz="2200" b="1">
+                <a:solidFill>
+                  <a:srgbClr val="38BDF8"/>
                 </a:solidFill>
                 <a:latin typeface="Segoe UI"/>
               </a:defRPr>
@@ -6119,14 +6151,14 @@
         </p:nvSpPr>
         <p:spPr>
           <a:xfrm>
-            <a:off x="731520" y="1188720"/>
-            <a:ext cx="10728655" cy="36576"/>
+            <a:off x="548640" y="1005840"/>
+            <a:ext cx="11094415" cy="27432"/>
           </a:xfrm>
           <a:prstGeom prst="rect">
             <a:avLst/>
           </a:prstGeom>
           <a:solidFill>
-            <a:srgbClr val="38BDF8"/>
+            <a:srgbClr val="0D9488"/>
           </a:solidFill>
           <a:ln>
             <a:noFill/>
@@ -6162,8 +6194,8 @@
         </p:nvSpPr>
         <p:spPr>
           <a:xfrm>
-            <a:off x="731520" y="1371600"/>
-            <a:ext cx="10728655" cy="4937760"/>
+            <a:off x="548640" y="1143000"/>
+            <a:ext cx="11094415" cy="5303520"/>
           </a:xfrm>
           <a:prstGeom prst="rect">
             <a:avLst/>
@@ -6171,64 +6203,64 @@
           <a:noFill/>
         </p:spPr>
         <p:txBody>
-          <a:bodyPr wrap="square">
+          <a:bodyPr wrap="square" lIns="0" tIns="0" rIns="0" bIns="0">
             <a:spAutoFit/>
           </a:bodyPr>
           <a:lstStyle/>
           <a:p>
             <a:pPr>
               <a:spcAft>
-                <a:spcPts val="800"/>
-              </a:spcAft>
-              <a:defRPr sz="2000" b="1">
-                <a:solidFill>
-                  <a:srgbClr val="94A3B8"/>
-                </a:solidFill>
-                <a:latin typeface="Segoe UI"/>
-              </a:defRPr>
-            </a:pPr>
-            <a:r>
-              <a:t>**Key Technical Innovations &amp; System Comebacks**</a:t>
-            </a:r>
-          </a:p>
-          <a:p>
-            <a:pPr>
-              <a:spcAft>
                 <a:spcPts val="400"/>
               </a:spcAft>
-              <a:defRPr sz="1400">
-                <a:solidFill>
-                  <a:srgbClr val="F1F5F9"/>
-                </a:solidFill>
-                <a:latin typeface="Segoe UI"/>
-              </a:defRPr>
-            </a:pPr>
-            <a:r>
-              <a:t>1. JS SPA Black Hole Fix: Replaced static extraction with automated Playwright Chromium auto-scrolling (`render.py`), jumping text extraction from 368 chars $\rightarrow$ 1,706 chars on JavaScript SPAs.</a:t>
-            </a:r>
-          </a:p>
-          <a:p>
-            <a:pPr>
-              <a:spcAft>
-                <a:spcPts val="400"/>
-              </a:spcAft>
-              <a:defRPr sz="1400">
-                <a:solidFill>
-                  <a:srgbClr val="F1F5F9"/>
-                </a:solidFill>
-                <a:latin typeface="Segoe UI"/>
-              </a:defRPr>
-            </a:pPr>
-            <a:r>
-              <a:t>2. CTA Erasure Recovery: Solved `trafilatura` button removal by building AST CTA Collectors (`_CtaCollector`) that attach primary buttons directly to chunk metadata.</a:t>
-            </a:r>
-          </a:p>
-          <a:p>
-            <a:pPr>
-              <a:spcAft>
-                <a:spcPts val="400"/>
-              </a:spcAft>
-              <a:defRPr sz="1400">
+              <a:defRPr sz="1700" b="1">
+                <a:solidFill>
+                  <a:srgbClr val="2DD4BF"/>
+                </a:solidFill>
+                <a:latin typeface="Segoe UI"/>
+              </a:defRPr>
+            </a:pPr>
+            <a:r>
+              <a:t>Key Technical Innovations &amp; System Comebacks</a:t>
+            </a:r>
+          </a:p>
+          <a:p>
+            <a:pPr>
+              <a:spcAft>
+                <a:spcPts val="250"/>
+              </a:spcAft>
+              <a:defRPr sz="1300">
+                <a:solidFill>
+                  <a:srgbClr val="F1F5F9"/>
+                </a:solidFill>
+                <a:latin typeface="Segoe UI"/>
+              </a:defRPr>
+            </a:pPr>
+            <a:r>
+              <a:t>1. JS SPA Black Hole Fix: Replaced static extraction with Playwright Chromium auto-scrolling (`render.py`), jumping text extraction from 368 chars $\rightarrow$ 1,706 chars on JavaScript SPAs.</a:t>
+            </a:r>
+          </a:p>
+          <a:p>
+            <a:pPr>
+              <a:spcAft>
+                <a:spcPts val="250"/>
+              </a:spcAft>
+              <a:defRPr sz="1300">
+                <a:solidFill>
+                  <a:srgbClr val="F1F5F9"/>
+                </a:solidFill>
+                <a:latin typeface="Segoe UI"/>
+              </a:defRPr>
+            </a:pPr>
+            <a:r>
+              <a:t>2. CTA Erasure Recovery: Solved `trafilatura` button removal by building AST CTA Collectors (`_CtaCollector`) attaching primary buttons to chunk metadata.</a:t>
+            </a:r>
+          </a:p>
+          <a:p>
+            <a:pPr>
+              <a:spcAft>
+                <a:spcPts val="250"/>
+              </a:spcAft>
+              <a:defRPr sz="1300">
                 <a:solidFill>
                   <a:srgbClr val="F1F5F9"/>
                 </a:solidFill>
@@ -6242,9 +6274,9 @@
           <a:p>
             <a:pPr>
               <a:spcAft>
-                <a:spcPts val="400"/>
-              </a:spcAft>
-              <a:defRPr sz="1400">
+                <a:spcPts val="250"/>
+              </a:spcAft>
+              <a:defRPr sz="1300">
                 <a:solidFill>
                   <a:srgbClr val="F1F5F9"/>
                 </a:solidFill>
@@ -6258,9 +6290,9 @@
           <a:p>
             <a:pPr>
               <a:spcAft>
-                <a:spcPts val="400"/>
-              </a:spcAft>
-              <a:defRPr sz="1400">
+                <a:spcPts val="250"/>
+              </a:spcAft>
+              <a:defRPr sz="1300">
                 <a:solidFill>
                   <a:srgbClr val="F1F5F9"/>
                 </a:solidFill>
@@ -6306,7 +6338,7 @@
             <a:avLst/>
           </a:prstGeom>
           <a:solidFill>
-            <a:srgbClr val="0F172A"/>
+            <a:srgbClr val="090D16"/>
           </a:solidFill>
           <a:ln>
             <a:noFill/>
@@ -6342,8 +6374,8 @@
         </p:nvSpPr>
         <p:spPr>
           <a:xfrm>
-            <a:off x="731520" y="365760"/>
-            <a:ext cx="10728655" cy="822960"/>
+            <a:off x="548640" y="274320"/>
+            <a:ext cx="11094415" cy="685800"/>
           </a:xfrm>
           <a:prstGeom prst="rect">
             <a:avLst/>
@@ -6351,15 +6383,15 @@
           <a:noFill/>
         </p:spPr>
         <p:txBody>
-          <a:bodyPr wrap="square">
+          <a:bodyPr wrap="square" lIns="0" tIns="0" rIns="0" bIns="0">
             <a:spAutoFit/>
           </a:bodyPr>
           <a:lstStyle/>
           <a:p>
             <a:pPr>
-              <a:defRPr sz="2600" b="1">
-                <a:solidFill>
-                  <a:srgbClr val="818CF8"/>
+              <a:defRPr sz="2200" b="1">
+                <a:solidFill>
+                  <a:srgbClr val="38BDF8"/>
                 </a:solidFill>
                 <a:latin typeface="Segoe UI"/>
               </a:defRPr>
@@ -6378,14 +6410,14 @@
         </p:nvSpPr>
         <p:spPr>
           <a:xfrm>
-            <a:off x="731520" y="1188720"/>
-            <a:ext cx="10728655" cy="36576"/>
+            <a:off x="548640" y="1005840"/>
+            <a:ext cx="11094415" cy="27432"/>
           </a:xfrm>
           <a:prstGeom prst="rect">
             <a:avLst/>
           </a:prstGeom>
           <a:solidFill>
-            <a:srgbClr val="38BDF8"/>
+            <a:srgbClr val="0D9488"/>
           </a:solidFill>
           <a:ln>
             <a:noFill/>
@@ -6421,8 +6453,8 @@
         </p:nvSpPr>
         <p:spPr>
           <a:xfrm>
-            <a:off x="731520" y="1371600"/>
-            <a:ext cx="10728655" cy="4937760"/>
+            <a:off x="548640" y="1143000"/>
+            <a:ext cx="11094415" cy="5303520"/>
           </a:xfrm>
           <a:prstGeom prst="rect">
             <a:avLst/>
@@ -6430,32 +6462,32 @@
           <a:noFill/>
         </p:spPr>
         <p:txBody>
-          <a:bodyPr wrap="square">
+          <a:bodyPr wrap="square" lIns="0" tIns="0" rIns="0" bIns="0">
             <a:spAutoFit/>
           </a:bodyPr>
           <a:lstStyle/>
           <a:p>
             <a:pPr>
               <a:spcAft>
-                <a:spcPts val="800"/>
-              </a:spcAft>
-              <a:defRPr sz="2000" b="1">
-                <a:solidFill>
-                  <a:srgbClr val="94A3B8"/>
-                </a:solidFill>
-                <a:latin typeface="Segoe UI"/>
-              </a:defRPr>
-            </a:pPr>
-            <a:r>
-              <a:t>**First Impression Engine (FIE)**</a:t>
-            </a:r>
-          </a:p>
-          <a:p>
-            <a:pPr>
-              <a:spcAft>
                 <a:spcPts val="400"/>
               </a:spcAft>
-              <a:defRPr sz="1400">
+              <a:defRPr sz="1700" b="1">
+                <a:solidFill>
+                  <a:srgbClr val="2DD4BF"/>
+                </a:solidFill>
+                <a:latin typeface="Segoe UI"/>
+              </a:defRPr>
+            </a:pPr>
+            <a:r>
+              <a:t>First Impression Engine (FIE)</a:t>
+            </a:r>
+          </a:p>
+          <a:p>
+            <a:pPr>
+              <a:spcAft>
+                <a:spcPts val="250"/>
+              </a:spcAft>
+              <a:defRPr sz="1300">
                 <a:solidFill>
                   <a:srgbClr val="F1F5F9"/>
                 </a:solidFill>
@@ -6469,113 +6501,113 @@
           <a:p>
             <a:pPr>
               <a:spcAft>
-                <a:spcPts val="400"/>
-              </a:spcAft>
-              <a:defRPr sz="1400">
-                <a:solidFill>
-                  <a:srgbClr val="F1F5F9"/>
-                </a:solidFill>
-                <a:latin typeface="Segoe UI"/>
-              </a:defRPr>
-            </a:pPr>
-            <a:r>
-              <a:t>• Core Problem: Founders and product teams suffer from the *curse of knowledge*—they cannot experience their own public site as an uninitiated stranger. Traditional tools audit SEO or page speed, but miss product clarity, value propositions, and UX friction.</a:t>
-            </a:r>
-          </a:p>
-          <a:p>
-            <a:pPr>
-              <a:spcAft>
-                <a:spcPts val="400"/>
-              </a:spcAft>
-              <a:defRPr sz="1400">
-                <a:solidFill>
-                  <a:srgbClr val="F1F5F9"/>
-                </a:solidFill>
-                <a:latin typeface="Segoe UI"/>
-              </a:defRPr>
-            </a:pPr>
-            <a:r>
-              <a:t>• Solution: An autonomous agentic platform that crawls public landing pages, ingests visual &amp; text content into ChromaDB, executes ReAct exploration loops, and evaluates product presentation through a multi-persona panel.</a:t>
-            </a:r>
-          </a:p>
-          <a:p>
-            <a:pPr>
-              <a:spcAft>
-                <a:spcPts val="400"/>
-              </a:spcAft>
-              <a:defRPr sz="1400">
-                <a:solidFill>
-                  <a:srgbClr val="F1F5F9"/>
-                </a:solidFill>
-                <a:latin typeface="Segoe UI"/>
-              </a:defRPr>
-            </a:pPr>
-            <a:r>
-              <a:t>• Key System Capabilities:</a:t>
-            </a:r>
-          </a:p>
-          <a:p>
-            <a:pPr>
-              <a:spcAft>
-                <a:spcPts val="400"/>
-              </a:spcAft>
-              <a:defRPr sz="1400">
-                <a:solidFill>
-                  <a:srgbClr val="F1F5F9"/>
-                </a:solidFill>
-                <a:latin typeface="Segoe UI"/>
-              </a:defRPr>
-            </a:pPr>
-            <a:r>
-              <a:t>• Fail-Closed Compliance: Strict `robots.txt` gate &amp; public-data-only constraint.</a:t>
-            </a:r>
-          </a:p>
-          <a:p>
-            <a:pPr>
-              <a:spcAft>
-                <a:spcPts val="400"/>
-              </a:spcAft>
-              <a:defRPr sz="1400">
-                <a:solidFill>
-                  <a:srgbClr val="F1F5F9"/>
-                </a:solidFill>
-                <a:latin typeface="Segoe UI"/>
-              </a:defRPr>
-            </a:pPr>
-            <a:r>
-              <a:t>• Multimodal Visual Intelligence: NVIDIA VLM vision captioning for dashboard UI screenshots (`nemotron-3-nano-omni-30b`).</a:t>
-            </a:r>
-          </a:p>
-          <a:p>
-            <a:pPr>
-              <a:spcAft>
-                <a:spcPts val="400"/>
-              </a:spcAft>
-              <a:defRPr sz="1400">
-                <a:solidFill>
-                  <a:srgbClr val="F1F5F9"/>
-                </a:solidFill>
-                <a:latin typeface="Segoe UI"/>
-              </a:defRPr>
-            </a:pPr>
-            <a:r>
-              <a:t>• Zero-Hallucination Pipeline: 5-layer trust verification stack guaranteeing backed claims and canonical URL citations.</a:t>
-            </a:r>
-          </a:p>
-          <a:p>
-            <a:pPr>
-              <a:spcAft>
-                <a:spcPts val="400"/>
-              </a:spcAft>
-              <a:defRPr sz="1400">
-                <a:solidFill>
-                  <a:srgbClr val="F1F5F9"/>
-                </a:solidFill>
-                <a:latin typeface="Segoe UI"/>
-              </a:defRPr>
-            </a:pPr>
-            <a:r>
-              <a:t>• Multi-Channel Delivery: FastAPI REST API, live SSE event bus, FastMCP stdio server, Netlify static web publishing, and automated PDF datasheets.</a:t>
+                <a:spcPts val="250"/>
+              </a:spcAft>
+              <a:defRPr sz="1300">
+                <a:solidFill>
+                  <a:srgbClr val="F1F5F9"/>
+                </a:solidFill>
+                <a:latin typeface="Segoe UI"/>
+              </a:defRPr>
+            </a:pPr>
+            <a:r>
+              <a:t>• Author: ~ Keshav Kakani</a:t>
+            </a:r>
+          </a:p>
+          <a:p>
+            <a:pPr>
+              <a:spcAft>
+                <a:spcPts val="250"/>
+              </a:spcAft>
+              <a:defRPr sz="1300">
+                <a:solidFill>
+                  <a:srgbClr val="F1F5F9"/>
+                </a:solidFill>
+                <a:latin typeface="Segoe UI"/>
+              </a:defRPr>
+            </a:pPr>
+            <a:r>
+              <a:t>• GitHub Repository: https://github.com/keshav9926/First-Impression-(https://github.com/keshav9926/First-Impression-)</a:t>
+            </a:r>
+          </a:p>
+          <a:p>
+            <a:pPr>
+              <a:spcAft>
+                <a:spcPts val="250"/>
+              </a:spcAft>
+              <a:defRPr sz="1300">
+                <a:solidFill>
+                  <a:srgbClr val="F1F5F9"/>
+                </a:solidFill>
+                <a:latin typeface="Segoe UI"/>
+              </a:defRPr>
+            </a:pPr>
+            <a:r>
+              <a:t>• Live Deployed Reports:</a:t>
+            </a:r>
+          </a:p>
+          <a:p>
+            <a:pPr>
+              <a:spcAft>
+                <a:spcPts val="250"/>
+              </a:spcAft>
+              <a:defRPr sz="1300">
+                <a:solidFill>
+                  <a:srgbClr val="F1F5F9"/>
+                </a:solidFill>
+                <a:latin typeface="Segoe UI"/>
+              </a:defRPr>
+            </a:pPr>
+            <a:r>
+              <a:t>• Vortexify Report: firstimpressione.netlify.app/vortexify(https://firstimpressione.netlify.app/vortexify)</a:t>
+            </a:r>
+          </a:p>
+          <a:p>
+            <a:pPr>
+              <a:spcAft>
+                <a:spcPts val="250"/>
+              </a:spcAft>
+              <a:defRPr sz="1300">
+                <a:solidFill>
+                  <a:srgbClr val="F1F5F9"/>
+                </a:solidFill>
+                <a:latin typeface="Segoe UI"/>
+              </a:defRPr>
+            </a:pPr>
+            <a:r>
+              <a:t>• KAINest Report: firstimpressione.netlify.app/kainest(https://firstimpressione.netlify.app/kainest)</a:t>
+            </a:r>
+          </a:p>
+          <a:p>
+            <a:pPr>
+              <a:spcAft>
+                <a:spcPts val="250"/>
+              </a:spcAft>
+              <a:defRPr sz="1300">
+                <a:solidFill>
+                  <a:srgbClr val="F1F5F9"/>
+                </a:solidFill>
+                <a:latin typeface="Segoe UI"/>
+              </a:defRPr>
+            </a:pPr>
+            <a:r>
+              <a:t>• Core Problem: Founders suffer from the *curse of knowledge*—they cannot experience their own public site as an uninitiated stranger. Traditional tools audit SEO or page speed, but miss product clarity, value propositions, and UX friction.</a:t>
+            </a:r>
+          </a:p>
+          <a:p>
+            <a:pPr>
+              <a:spcAft>
+                <a:spcPts val="250"/>
+              </a:spcAft>
+              <a:defRPr sz="1300">
+                <a:solidFill>
+                  <a:srgbClr val="F1F5F9"/>
+                </a:solidFill>
+                <a:latin typeface="Segoe UI"/>
+              </a:defRPr>
+            </a:pPr>
+            <a:r>
+              <a:t>• Solution: Autonomous agentic platform crawling public landing pages, ingesting visual &amp; text content into ChromaDB, executing ReAct loops, and evaluating product presentation through a multi-persona panel.</a:t>
             </a:r>
           </a:p>
         </p:txBody>
@@ -6613,7 +6645,7 @@
             <a:avLst/>
           </a:prstGeom>
           <a:solidFill>
-            <a:srgbClr val="0F172A"/>
+            <a:srgbClr val="090D16"/>
           </a:solidFill>
           <a:ln>
             <a:noFill/>
@@ -6649,8 +6681,8 @@
         </p:nvSpPr>
         <p:spPr>
           <a:xfrm>
-            <a:off x="731520" y="365760"/>
-            <a:ext cx="10728655" cy="822960"/>
+            <a:off x="548640" y="274320"/>
+            <a:ext cx="11094415" cy="685800"/>
           </a:xfrm>
           <a:prstGeom prst="rect">
             <a:avLst/>
@@ -6658,15 +6690,15 @@
           <a:noFill/>
         </p:spPr>
         <p:txBody>
-          <a:bodyPr wrap="square">
+          <a:bodyPr wrap="square" lIns="0" tIns="0" rIns="0" bIns="0">
             <a:spAutoFit/>
           </a:bodyPr>
           <a:lstStyle/>
           <a:p>
             <a:pPr>
-              <a:defRPr sz="2600" b="1">
-                <a:solidFill>
-                  <a:srgbClr val="818CF8"/>
+              <a:defRPr sz="2200" b="1">
+                <a:solidFill>
+                  <a:srgbClr val="38BDF8"/>
                 </a:solidFill>
                 <a:latin typeface="Segoe UI"/>
               </a:defRPr>
@@ -6685,14 +6717,14 @@
         </p:nvSpPr>
         <p:spPr>
           <a:xfrm>
-            <a:off x="731520" y="1188720"/>
-            <a:ext cx="10728655" cy="36576"/>
+            <a:off x="548640" y="1005840"/>
+            <a:ext cx="11094415" cy="27432"/>
           </a:xfrm>
           <a:prstGeom prst="rect">
             <a:avLst/>
           </a:prstGeom>
           <a:solidFill>
-            <a:srgbClr val="38BDF8"/>
+            <a:srgbClr val="0D9488"/>
           </a:solidFill>
           <a:ln>
             <a:noFill/>
@@ -6728,8 +6760,8 @@
         </p:nvSpPr>
         <p:spPr>
           <a:xfrm>
-            <a:off x="731520" y="1371600"/>
-            <a:ext cx="10728655" cy="4937760"/>
+            <a:off x="548640" y="1143000"/>
+            <a:ext cx="11094415" cy="5303520"/>
           </a:xfrm>
           <a:prstGeom prst="rect">
             <a:avLst/>
@@ -6737,32 +6769,32 @@
           <a:noFill/>
         </p:spPr>
         <p:txBody>
-          <a:bodyPr wrap="square">
+          <a:bodyPr wrap="square" lIns="0" tIns="0" rIns="0" bIns="0">
             <a:spAutoFit/>
           </a:bodyPr>
           <a:lstStyle/>
           <a:p>
             <a:pPr>
               <a:spcAft>
-                <a:spcPts val="800"/>
-              </a:spcAft>
-              <a:defRPr sz="2000" b="1">
-                <a:solidFill>
-                  <a:srgbClr val="94A3B8"/>
-                </a:solidFill>
-                <a:latin typeface="Segoe UI"/>
-              </a:defRPr>
-            </a:pPr>
-            <a:r>
-              <a:t>**Core System Architectural Principles for Technical Discussions**</a:t>
-            </a:r>
-          </a:p>
-          <a:p>
-            <a:pPr>
-              <a:spcAft>
                 <a:spcPts val="400"/>
               </a:spcAft>
-              <a:defRPr sz="1400">
+              <a:defRPr sz="1700" b="1">
+                <a:solidFill>
+                  <a:srgbClr val="2DD4BF"/>
+                </a:solidFill>
+                <a:latin typeface="Segoe UI"/>
+              </a:defRPr>
+            </a:pPr>
+            <a:r>
+              <a:t>Core System Architectural Principles for Technical Discussions</a:t>
+            </a:r>
+          </a:p>
+          <a:p>
+            <a:pPr>
+              <a:spcAft>
+                <a:spcPts val="250"/>
+              </a:spcAft>
+              <a:defRPr sz="1300">
                 <a:solidFill>
                   <a:srgbClr val="F1F5F9"/>
                 </a:solidFill>
@@ -6776,9 +6808,9 @@
           <a:p>
             <a:pPr>
               <a:spcAft>
-                <a:spcPts val="400"/>
-              </a:spcAft>
-              <a:defRPr sz="1400">
+                <a:spcPts val="250"/>
+              </a:spcAft>
+              <a:defRPr sz="1300">
                 <a:solidFill>
                   <a:srgbClr val="F1F5F9"/>
                 </a:solidFill>
@@ -6792,9 +6824,9 @@
           <a:p>
             <a:pPr>
               <a:spcAft>
-                <a:spcPts val="400"/>
-              </a:spcAft>
-              <a:defRPr sz="1400">
+                <a:spcPts val="250"/>
+              </a:spcAft>
+              <a:defRPr sz="1300">
                 <a:solidFill>
                   <a:srgbClr val="F1F5F9"/>
                 </a:solidFill>
@@ -6808,9 +6840,9 @@
           <a:p>
             <a:pPr>
               <a:spcAft>
-                <a:spcPts val="400"/>
-              </a:spcAft>
-              <a:defRPr sz="1400">
+                <a:spcPts val="250"/>
+              </a:spcAft>
+              <a:defRPr sz="1300">
                 <a:solidFill>
                   <a:srgbClr val="F1F5F9"/>
                 </a:solidFill>
@@ -6824,9 +6856,9 @@
           <a:p>
             <a:pPr>
               <a:spcAft>
-                <a:spcPts val="400"/>
-              </a:spcAft>
-              <a:defRPr sz="1400">
+                <a:spcPts val="250"/>
+              </a:spcAft>
+              <a:defRPr sz="1300">
                 <a:solidFill>
                   <a:srgbClr val="F1F5F9"/>
                 </a:solidFill>
@@ -6872,7 +6904,7 @@
             <a:avLst/>
           </a:prstGeom>
           <a:solidFill>
-            <a:srgbClr val="0F172A"/>
+            <a:srgbClr val="090D16"/>
           </a:solidFill>
           <a:ln>
             <a:noFill/>
@@ -6908,8 +6940,8 @@
         </p:nvSpPr>
         <p:spPr>
           <a:xfrm>
-            <a:off x="731520" y="365760"/>
-            <a:ext cx="10728655" cy="822960"/>
+            <a:off x="548640" y="274320"/>
+            <a:ext cx="11094415" cy="685800"/>
           </a:xfrm>
           <a:prstGeom prst="rect">
             <a:avLst/>
@@ -6917,15 +6949,15 @@
           <a:noFill/>
         </p:spPr>
         <p:txBody>
-          <a:bodyPr wrap="square">
+          <a:bodyPr wrap="square" lIns="0" tIns="0" rIns="0" bIns="0">
             <a:spAutoFit/>
           </a:bodyPr>
           <a:lstStyle/>
           <a:p>
             <a:pPr>
-              <a:defRPr sz="2600" b="1">
-                <a:solidFill>
-                  <a:srgbClr val="818CF8"/>
+              <a:defRPr sz="2200" b="1">
+                <a:solidFill>
+                  <a:srgbClr val="38BDF8"/>
                 </a:solidFill>
                 <a:latin typeface="Segoe UI"/>
               </a:defRPr>
@@ -6944,14 +6976,14 @@
         </p:nvSpPr>
         <p:spPr>
           <a:xfrm>
-            <a:off x="731520" y="1188720"/>
-            <a:ext cx="10728655" cy="36576"/>
+            <a:off x="548640" y="1005840"/>
+            <a:ext cx="11094415" cy="27432"/>
           </a:xfrm>
           <a:prstGeom prst="rect">
             <a:avLst/>
           </a:prstGeom>
           <a:solidFill>
-            <a:srgbClr val="38BDF8"/>
+            <a:srgbClr val="0D9488"/>
           </a:solidFill>
           <a:ln>
             <a:noFill/>
@@ -6987,18 +7019,18 @@
         </p:nvSpPr>
         <p:spPr>
           <a:xfrm>
-            <a:off x="731520" y="1371600"/>
-            <a:ext cx="10728655" cy="4937760"/>
+            <a:off x="548640" y="1143000"/>
+            <a:ext cx="11094415" cy="5303520"/>
           </a:xfrm>
           <a:prstGeom prst="roundRect">
             <a:avLst/>
           </a:prstGeom>
           <a:solidFill>
-            <a:srgbClr val="1E293B"/>
+            <a:srgbClr val="0F172A"/>
           </a:solidFill>
           <a:ln>
             <a:solidFill>
-              <a:srgbClr val="38BDF8"/>
+              <a:srgbClr val="0D9488"/>
             </a:solidFill>
           </a:ln>
         </p:spPr>
@@ -7032,8 +7064,8 @@
         </p:nvSpPr>
         <p:spPr>
           <a:xfrm>
-            <a:off x="914400" y="1463040"/>
-            <a:ext cx="10362895" cy="4754880"/>
+            <a:off x="685800" y="1234440"/>
+            <a:ext cx="10820095" cy="5120640"/>
           </a:xfrm>
           <a:prstGeom prst="rect">
             <a:avLst/>
@@ -7041,13 +7073,13 @@
           <a:noFill/>
         </p:spPr>
         <p:txBody>
-          <a:bodyPr wrap="square">
+          <a:bodyPr wrap="square" lIns="0" tIns="0" rIns="0" bIns="0">
             <a:spAutoFit/>
           </a:bodyPr>
           <a:lstStyle/>
           <a:p>
             <a:pPr>
-              <a:defRPr sz="1100">
+              <a:defRPr sz="850">
                 <a:solidFill>
                   <a:srgbClr val="E2E8F0"/>
                 </a:solidFill>
@@ -7337,7 +7369,7 @@
             <a:avLst/>
           </a:prstGeom>
           <a:solidFill>
-            <a:srgbClr val="0F172A"/>
+            <a:srgbClr val="090D16"/>
           </a:solidFill>
           <a:ln>
             <a:noFill/>
@@ -7373,8 +7405,8 @@
         </p:nvSpPr>
         <p:spPr>
           <a:xfrm>
-            <a:off x="731520" y="365760"/>
-            <a:ext cx="10728655" cy="822960"/>
+            <a:off x="548640" y="274320"/>
+            <a:ext cx="11094415" cy="685800"/>
           </a:xfrm>
           <a:prstGeom prst="rect">
             <a:avLst/>
@@ -7382,15 +7414,15 @@
           <a:noFill/>
         </p:spPr>
         <p:txBody>
-          <a:bodyPr wrap="square">
+          <a:bodyPr wrap="square" lIns="0" tIns="0" rIns="0" bIns="0">
             <a:spAutoFit/>
           </a:bodyPr>
           <a:lstStyle/>
           <a:p>
             <a:pPr>
-              <a:defRPr sz="2600" b="1">
-                <a:solidFill>
-                  <a:srgbClr val="818CF8"/>
+              <a:defRPr sz="2200" b="1">
+                <a:solidFill>
+                  <a:srgbClr val="38BDF8"/>
                 </a:solidFill>
                 <a:latin typeface="Segoe UI"/>
               </a:defRPr>
@@ -7409,14 +7441,14 @@
         </p:nvSpPr>
         <p:spPr>
           <a:xfrm>
-            <a:off x="731520" y="1188720"/>
-            <a:ext cx="10728655" cy="36576"/>
+            <a:off x="548640" y="1005840"/>
+            <a:ext cx="11094415" cy="27432"/>
           </a:xfrm>
           <a:prstGeom prst="rect">
             <a:avLst/>
           </a:prstGeom>
           <a:solidFill>
-            <a:srgbClr val="38BDF8"/>
+            <a:srgbClr val="0D9488"/>
           </a:solidFill>
           <a:ln>
             <a:noFill/>
@@ -7452,8 +7484,8 @@
         </p:nvSpPr>
         <p:spPr>
           <a:xfrm>
-            <a:off x="731520" y="1371600"/>
-            <a:ext cx="10728655" cy="4937760"/>
+            <a:off x="548640" y="1143000"/>
+            <a:ext cx="11094415" cy="5303520"/>
           </a:xfrm>
           <a:prstGeom prst="rect">
             <a:avLst/>
@@ -7461,32 +7493,32 @@
           <a:noFill/>
         </p:spPr>
         <p:txBody>
-          <a:bodyPr wrap="square">
+          <a:bodyPr wrap="square" lIns="0" tIns="0" rIns="0" bIns="0">
             <a:spAutoFit/>
           </a:bodyPr>
           <a:lstStyle/>
           <a:p>
             <a:pPr>
               <a:spcAft>
-                <a:spcPts val="800"/>
-              </a:spcAft>
-              <a:defRPr sz="2000" b="1">
-                <a:solidFill>
-                  <a:srgbClr val="94A3B8"/>
-                </a:solidFill>
-                <a:latin typeface="Segoe UI"/>
-              </a:defRPr>
-            </a:pPr>
-            <a:r>
-              <a:t>**Multi-Stage Web Harvesting (`app/ingestion/`)**</a:t>
-            </a:r>
-          </a:p>
-          <a:p>
-            <a:pPr>
-              <a:spcAft>
                 <a:spcPts val="400"/>
               </a:spcAft>
-              <a:defRPr sz="1400">
+              <a:defRPr sz="1700" b="1">
+                <a:solidFill>
+                  <a:srgbClr val="2DD4BF"/>
+                </a:solidFill>
+                <a:latin typeface="Segoe UI"/>
+              </a:defRPr>
+            </a:pPr>
+            <a:r>
+              <a:t>Multi-Stage Web Harvesting (`app/ingestion/`)</a:t>
+            </a:r>
+          </a:p>
+          <a:p>
+            <a:pPr>
+              <a:spcAft>
+                <a:spcPts val="250"/>
+              </a:spcAft>
+              <a:defRPr sz="1300">
                 <a:solidFill>
                   <a:srgbClr val="F1F5F9"/>
                 </a:solidFill>
@@ -7500,9 +7532,9 @@
           <a:p>
             <a:pPr>
               <a:spcAft>
-                <a:spcPts val="400"/>
-              </a:spcAft>
-              <a:defRPr sz="1400">
+                <a:spcPts val="250"/>
+              </a:spcAft>
+              <a:defRPr sz="1300">
                 <a:solidFill>
                   <a:srgbClr val="F1F5F9"/>
                 </a:solidFill>
@@ -7516,9 +7548,9 @@
           <a:p>
             <a:pPr>
               <a:spcAft>
-                <a:spcPts val="400"/>
-              </a:spcAft>
-              <a:defRPr sz="1400">
+                <a:spcPts val="250"/>
+              </a:spcAft>
+              <a:defRPr sz="1300">
                 <a:solidFill>
                   <a:srgbClr val="F1F5F9"/>
                 </a:solidFill>
@@ -7532,9 +7564,9 @@
           <a:p>
             <a:pPr>
               <a:spcAft>
-                <a:spcPts val="400"/>
-              </a:spcAft>
-              <a:defRPr sz="1400">
+                <a:spcPts val="250"/>
+              </a:spcAft>
+              <a:defRPr sz="1300">
                 <a:solidFill>
                   <a:srgbClr val="F1F5F9"/>
                 </a:solidFill>
@@ -7548,9 +7580,9 @@
           <a:p>
             <a:pPr>
               <a:spcAft>
-                <a:spcPts val="400"/>
-              </a:spcAft>
-              <a:defRPr sz="1400">
+                <a:spcPts val="250"/>
+              </a:spcAft>
+              <a:defRPr sz="1300">
                 <a:solidFill>
                   <a:srgbClr val="F1F5F9"/>
                 </a:solidFill>
@@ -7596,7 +7628,7 @@
             <a:avLst/>
           </a:prstGeom>
           <a:solidFill>
-            <a:srgbClr val="0F172A"/>
+            <a:srgbClr val="090D16"/>
           </a:solidFill>
           <a:ln>
             <a:noFill/>
@@ -7632,8 +7664,8 @@
         </p:nvSpPr>
         <p:spPr>
           <a:xfrm>
-            <a:off x="731520" y="365760"/>
-            <a:ext cx="10728655" cy="822960"/>
+            <a:off x="548640" y="274320"/>
+            <a:ext cx="11094415" cy="685800"/>
           </a:xfrm>
           <a:prstGeom prst="rect">
             <a:avLst/>
@@ -7641,15 +7673,15 @@
           <a:noFill/>
         </p:spPr>
         <p:txBody>
-          <a:bodyPr wrap="square">
+          <a:bodyPr wrap="square" lIns="0" tIns="0" rIns="0" bIns="0">
             <a:spAutoFit/>
           </a:bodyPr>
           <a:lstStyle/>
           <a:p>
             <a:pPr>
-              <a:defRPr sz="2600" b="1">
-                <a:solidFill>
-                  <a:srgbClr val="818CF8"/>
+              <a:defRPr sz="2200" b="1">
+                <a:solidFill>
+                  <a:srgbClr val="38BDF8"/>
                 </a:solidFill>
                 <a:latin typeface="Segoe UI"/>
               </a:defRPr>
@@ -7668,14 +7700,14 @@
         </p:nvSpPr>
         <p:spPr>
           <a:xfrm>
-            <a:off x="731520" y="1188720"/>
-            <a:ext cx="10728655" cy="36576"/>
+            <a:off x="548640" y="1005840"/>
+            <a:ext cx="11094415" cy="27432"/>
           </a:xfrm>
           <a:prstGeom prst="rect">
             <a:avLst/>
           </a:prstGeom>
           <a:solidFill>
-            <a:srgbClr val="38BDF8"/>
+            <a:srgbClr val="0D9488"/>
           </a:solidFill>
           <a:ln>
             <a:noFill/>
@@ -7711,8 +7743,8 @@
         </p:nvSpPr>
         <p:spPr>
           <a:xfrm>
-            <a:off x="731520" y="1371600"/>
-            <a:ext cx="10728655" cy="4937760"/>
+            <a:off x="548640" y="1143000"/>
+            <a:ext cx="11094415" cy="5303520"/>
           </a:xfrm>
           <a:prstGeom prst="rect">
             <a:avLst/>
@@ -7720,32 +7752,32 @@
           <a:noFill/>
         </p:spPr>
         <p:txBody>
-          <a:bodyPr wrap="square">
+          <a:bodyPr wrap="square" lIns="0" tIns="0" rIns="0" bIns="0">
             <a:spAutoFit/>
           </a:bodyPr>
           <a:lstStyle/>
           <a:p>
             <a:pPr>
               <a:spcAft>
-                <a:spcPts val="800"/>
-              </a:spcAft>
-              <a:defRPr sz="2000" b="1">
-                <a:solidFill>
-                  <a:srgbClr val="94A3B8"/>
-                </a:solidFill>
-                <a:latin typeface="Segoe UI"/>
-              </a:defRPr>
-            </a:pPr>
-            <a:r>
-              <a:t>**Custom Paragraph-Aware Chunker (`app/ingestion/chunker.py`)**</a:t>
-            </a:r>
-          </a:p>
-          <a:p>
-            <a:pPr>
-              <a:spcAft>
                 <a:spcPts val="400"/>
               </a:spcAft>
-              <a:defRPr sz="1400">
+              <a:defRPr sz="1700" b="1">
+                <a:solidFill>
+                  <a:srgbClr val="2DD4BF"/>
+                </a:solidFill>
+                <a:latin typeface="Segoe UI"/>
+              </a:defRPr>
+            </a:pPr>
+            <a:r>
+              <a:t>Custom Paragraph-Aware Chunker (`app/ingestion/chunker.py`)</a:t>
+            </a:r>
+          </a:p>
+          <a:p>
+            <a:pPr>
+              <a:spcAft>
+                <a:spcPts val="250"/>
+              </a:spcAft>
+              <a:defRPr sz="1300">
                 <a:solidFill>
                   <a:srgbClr val="F1F5F9"/>
                 </a:solidFill>
@@ -7759,9 +7791,9 @@
           <a:p>
             <a:pPr>
               <a:spcAft>
-                <a:spcPts val="400"/>
-              </a:spcAft>
-              <a:defRPr sz="1400">
+                <a:spcPts val="250"/>
+              </a:spcAft>
+              <a:defRPr sz="1300">
                 <a:solidFill>
                   <a:srgbClr val="F1F5F9"/>
                 </a:solidFill>
@@ -7775,9 +7807,9 @@
           <a:p>
             <a:pPr>
               <a:spcAft>
-                <a:spcPts val="400"/>
-              </a:spcAft>
-              <a:defRPr sz="1400">
+                <a:spcPts val="250"/>
+              </a:spcAft>
+              <a:defRPr sz="1300">
                 <a:solidFill>
                   <a:srgbClr val="F1F5F9"/>
                 </a:solidFill>
@@ -7791,9 +7823,9 @@
           <a:p>
             <a:pPr>
               <a:spcAft>
-                <a:spcPts val="400"/>
-              </a:spcAft>
-              <a:defRPr sz="1400">
+                <a:spcPts val="250"/>
+              </a:spcAft>
+              <a:defRPr sz="1300">
                 <a:solidFill>
                   <a:srgbClr val="F1F5F9"/>
                 </a:solidFill>
@@ -7807,9 +7839,9 @@
           <a:p>
             <a:pPr>
               <a:spcAft>
-                <a:spcPts val="400"/>
-              </a:spcAft>
-              <a:defRPr sz="1400">
+                <a:spcPts val="250"/>
+              </a:spcAft>
+              <a:defRPr sz="1300">
                 <a:solidFill>
                   <a:srgbClr val="F1F5F9"/>
                 </a:solidFill>
@@ -7823,9 +7855,9 @@
           <a:p>
             <a:pPr>
               <a:spcAft>
-                <a:spcPts val="400"/>
-              </a:spcAft>
-              <a:defRPr sz="1400">
+                <a:spcPts val="250"/>
+              </a:spcAft>
+              <a:defRPr sz="1300">
                 <a:solidFill>
                   <a:srgbClr val="F1F5F9"/>
                 </a:solidFill>
@@ -7839,9 +7871,9 @@
           <a:p>
             <a:pPr>
               <a:spcAft>
-                <a:spcPts val="400"/>
-              </a:spcAft>
-              <a:defRPr sz="1400">
+                <a:spcPts val="250"/>
+              </a:spcAft>
+              <a:defRPr sz="1300">
                 <a:solidFill>
                   <a:srgbClr val="F1F5F9"/>
                 </a:solidFill>
@@ -7887,7 +7919,7 @@
             <a:avLst/>
           </a:prstGeom>
           <a:solidFill>
-            <a:srgbClr val="0F172A"/>
+            <a:srgbClr val="090D16"/>
           </a:solidFill>
           <a:ln>
             <a:noFill/>
@@ -7923,8 +7955,8 @@
         </p:nvSpPr>
         <p:spPr>
           <a:xfrm>
-            <a:off x="731520" y="365760"/>
-            <a:ext cx="10728655" cy="822960"/>
+            <a:off x="548640" y="274320"/>
+            <a:ext cx="11094415" cy="685800"/>
           </a:xfrm>
           <a:prstGeom prst="rect">
             <a:avLst/>
@@ -7932,15 +7964,15 @@
           <a:noFill/>
         </p:spPr>
         <p:txBody>
-          <a:bodyPr wrap="square">
+          <a:bodyPr wrap="square" lIns="0" tIns="0" rIns="0" bIns="0">
             <a:spAutoFit/>
           </a:bodyPr>
           <a:lstStyle/>
           <a:p>
             <a:pPr>
-              <a:defRPr sz="2600" b="1">
-                <a:solidFill>
-                  <a:srgbClr val="818CF8"/>
+              <a:defRPr sz="2200" b="1">
+                <a:solidFill>
+                  <a:srgbClr val="38BDF8"/>
                 </a:solidFill>
                 <a:latin typeface="Segoe UI"/>
               </a:defRPr>
@@ -7959,14 +7991,14 @@
         </p:nvSpPr>
         <p:spPr>
           <a:xfrm>
-            <a:off x="731520" y="1188720"/>
-            <a:ext cx="10728655" cy="36576"/>
+            <a:off x="548640" y="1005840"/>
+            <a:ext cx="11094415" cy="27432"/>
           </a:xfrm>
           <a:prstGeom prst="rect">
             <a:avLst/>
           </a:prstGeom>
           <a:solidFill>
-            <a:srgbClr val="38BDF8"/>
+            <a:srgbClr val="0D9488"/>
           </a:solidFill>
           <a:ln>
             <a:noFill/>
@@ -8002,8 +8034,8 @@
         </p:nvSpPr>
         <p:spPr>
           <a:xfrm>
-            <a:off x="731520" y="1371600"/>
-            <a:ext cx="10728655" cy="4937760"/>
+            <a:off x="548640" y="1143000"/>
+            <a:ext cx="11094415" cy="5303520"/>
           </a:xfrm>
           <a:prstGeom prst="rect">
             <a:avLst/>
@@ -8011,32 +8043,32 @@
           <a:noFill/>
         </p:spPr>
         <p:txBody>
-          <a:bodyPr wrap="square">
+          <a:bodyPr wrap="square" lIns="0" tIns="0" rIns="0" bIns="0">
             <a:spAutoFit/>
           </a:bodyPr>
           <a:lstStyle/>
           <a:p>
             <a:pPr>
               <a:spcAft>
-                <a:spcPts val="800"/>
-              </a:spcAft>
-              <a:defRPr sz="2000" b="1">
-                <a:solidFill>
-                  <a:srgbClr val="94A3B8"/>
-                </a:solidFill>
-                <a:latin typeface="Segoe UI"/>
-              </a:defRPr>
-            </a:pPr>
-            <a:r>
-              <a:t>**Vector Indexing &amp; Storage Engine (`app/rag/`)**</a:t>
-            </a:r>
-          </a:p>
-          <a:p>
-            <a:pPr>
-              <a:spcAft>
                 <a:spcPts val="400"/>
               </a:spcAft>
-              <a:defRPr sz="1400">
+              <a:defRPr sz="1700" b="1">
+                <a:solidFill>
+                  <a:srgbClr val="2DD4BF"/>
+                </a:solidFill>
+                <a:latin typeface="Segoe UI"/>
+              </a:defRPr>
+            </a:pPr>
+            <a:r>
+              <a:t>Vector Indexing &amp; Storage Engine (`app/rag/`)</a:t>
+            </a:r>
+          </a:p>
+          <a:p>
+            <a:pPr>
+              <a:spcAft>
+                <a:spcPts val="250"/>
+              </a:spcAft>
+              <a:defRPr sz="1300">
                 <a:solidFill>
                   <a:srgbClr val="F1F5F9"/>
                 </a:solidFill>
@@ -8050,9 +8082,9 @@
           <a:p>
             <a:pPr>
               <a:spcAft>
-                <a:spcPts val="400"/>
-              </a:spcAft>
-              <a:defRPr sz="1400">
+                <a:spcPts val="250"/>
+              </a:spcAft>
+              <a:defRPr sz="1300">
                 <a:solidFill>
                   <a:srgbClr val="F1F5F9"/>
                 </a:solidFill>
@@ -8066,9 +8098,9 @@
           <a:p>
             <a:pPr>
               <a:spcAft>
-                <a:spcPts val="400"/>
-              </a:spcAft>
-              <a:defRPr sz="1400">
+                <a:spcPts val="250"/>
+              </a:spcAft>
+              <a:defRPr sz="1300">
                 <a:solidFill>
                   <a:srgbClr val="F1F5F9"/>
                 </a:solidFill>
@@ -8082,9 +8114,9 @@
           <a:p>
             <a:pPr>
               <a:spcAft>
-                <a:spcPts val="400"/>
-              </a:spcAft>
-              <a:defRPr sz="1400">
+                <a:spcPts val="250"/>
+              </a:spcAft>
+              <a:defRPr sz="1300">
                 <a:solidFill>
                   <a:srgbClr val="F1F5F9"/>
                 </a:solidFill>
@@ -8098,9 +8130,9 @@
           <a:p>
             <a:pPr>
               <a:spcAft>
-                <a:spcPts val="400"/>
-              </a:spcAft>
-              <a:defRPr sz="1400">
+                <a:spcPts val="250"/>
+              </a:spcAft>
+              <a:defRPr sz="1300">
                 <a:solidFill>
                   <a:srgbClr val="F1F5F9"/>
                 </a:solidFill>
@@ -8114,9 +8146,9 @@
           <a:p>
             <a:pPr>
               <a:spcAft>
-                <a:spcPts val="400"/>
-              </a:spcAft>
-              <a:defRPr sz="1400">
+                <a:spcPts val="250"/>
+              </a:spcAft>
+              <a:defRPr sz="1300">
                 <a:solidFill>
                   <a:srgbClr val="F1F5F9"/>
                 </a:solidFill>
@@ -8130,9 +8162,9 @@
           <a:p>
             <a:pPr>
               <a:spcAft>
-                <a:spcPts val="400"/>
-              </a:spcAft>
-              <a:defRPr sz="1400">
+                <a:spcPts val="250"/>
+              </a:spcAft>
+              <a:defRPr sz="1300">
                 <a:solidFill>
                   <a:srgbClr val="F1F5F9"/>
                 </a:solidFill>
@@ -8146,9 +8178,9 @@
           <a:p>
             <a:pPr>
               <a:spcAft>
-                <a:spcPts val="400"/>
-              </a:spcAft>
-              <a:defRPr sz="1400">
+                <a:spcPts val="250"/>
+              </a:spcAft>
+              <a:defRPr sz="1300">
                 <a:solidFill>
                   <a:srgbClr val="F1F5F9"/>
                 </a:solidFill>
@@ -8194,7 +8226,7 @@
             <a:avLst/>
           </a:prstGeom>
           <a:solidFill>
-            <a:srgbClr val="0F172A"/>
+            <a:srgbClr val="090D16"/>
           </a:solidFill>
           <a:ln>
             <a:noFill/>
@@ -8230,8 +8262,8 @@
         </p:nvSpPr>
         <p:spPr>
           <a:xfrm>
-            <a:off x="731520" y="365760"/>
-            <a:ext cx="10728655" cy="822960"/>
+            <a:off x="548640" y="274320"/>
+            <a:ext cx="11094415" cy="685800"/>
           </a:xfrm>
           <a:prstGeom prst="rect">
             <a:avLst/>
@@ -8239,15 +8271,15 @@
           <a:noFill/>
         </p:spPr>
         <p:txBody>
-          <a:bodyPr wrap="square">
+          <a:bodyPr wrap="square" lIns="0" tIns="0" rIns="0" bIns="0">
             <a:spAutoFit/>
           </a:bodyPr>
           <a:lstStyle/>
           <a:p>
             <a:pPr>
-              <a:defRPr sz="2600" b="1">
-                <a:solidFill>
-                  <a:srgbClr val="818CF8"/>
+              <a:defRPr sz="2200" b="1">
+                <a:solidFill>
+                  <a:srgbClr val="38BDF8"/>
                 </a:solidFill>
                 <a:latin typeface="Segoe UI"/>
               </a:defRPr>
@@ -8266,14 +8298,14 @@
         </p:nvSpPr>
         <p:spPr>
           <a:xfrm>
-            <a:off x="731520" y="1188720"/>
-            <a:ext cx="10728655" cy="36576"/>
+            <a:off x="548640" y="1005840"/>
+            <a:ext cx="11094415" cy="27432"/>
           </a:xfrm>
           <a:prstGeom prst="rect">
             <a:avLst/>
           </a:prstGeom>
           <a:solidFill>
-            <a:srgbClr val="38BDF8"/>
+            <a:srgbClr val="0D9488"/>
           </a:solidFill>
           <a:ln>
             <a:noFill/>
@@ -8309,8 +8341,8 @@
         </p:nvSpPr>
         <p:spPr>
           <a:xfrm>
-            <a:off x="731520" y="1371600"/>
-            <a:ext cx="10728655" cy="4937760"/>
+            <a:off x="548640" y="1143000"/>
+            <a:ext cx="11094415" cy="5303520"/>
           </a:xfrm>
           <a:prstGeom prst="rect">
             <a:avLst/>
@@ -8318,32 +8350,32 @@
           <a:noFill/>
         </p:spPr>
         <p:txBody>
-          <a:bodyPr wrap="square">
+          <a:bodyPr wrap="square" lIns="0" tIns="0" rIns="0" bIns="0">
             <a:spAutoFit/>
           </a:bodyPr>
           <a:lstStyle/>
           <a:p>
             <a:pPr>
               <a:spcAft>
-                <a:spcPts val="800"/>
-              </a:spcAft>
-              <a:defRPr sz="2000" b="1">
-                <a:solidFill>
-                  <a:srgbClr val="94A3B8"/>
-                </a:solidFill>
-                <a:latin typeface="Segoe UI"/>
-              </a:defRPr>
-            </a:pPr>
-            <a:r>
-              <a:t>**Multi-Arm Retrieval &amp; Reranking Architecture (`app/rag/`)**</a:t>
-            </a:r>
-          </a:p>
-          <a:p>
-            <a:pPr>
-              <a:spcAft>
                 <a:spcPts val="400"/>
               </a:spcAft>
-              <a:defRPr sz="1400">
+              <a:defRPr sz="1700" b="1">
+                <a:solidFill>
+                  <a:srgbClr val="2DD4BF"/>
+                </a:solidFill>
+                <a:latin typeface="Segoe UI"/>
+              </a:defRPr>
+            </a:pPr>
+            <a:r>
+              <a:t>Multi-Arm Retrieval &amp; Reranking Architecture (`app/rag/`)</a:t>
+            </a:r>
+          </a:p>
+          <a:p>
+            <a:pPr>
+              <a:spcAft>
+                <a:spcPts val="250"/>
+              </a:spcAft>
+              <a:defRPr sz="1300">
                 <a:solidFill>
                   <a:srgbClr val="F1F5F9"/>
                 </a:solidFill>
@@ -8357,9 +8389,9 @@
           <a:p>
             <a:pPr>
               <a:spcAft>
-                <a:spcPts val="400"/>
-              </a:spcAft>
-              <a:defRPr sz="1400">
+                <a:spcPts val="250"/>
+              </a:spcAft>
+              <a:defRPr sz="1300">
                 <a:solidFill>
                   <a:srgbClr val="F1F5F9"/>
                 </a:solidFill>
@@ -8373,9 +8405,9 @@
           <a:p>
             <a:pPr>
               <a:spcAft>
-                <a:spcPts val="400"/>
-              </a:spcAft>
-              <a:defRPr sz="1400">
+                <a:spcPts val="250"/>
+              </a:spcAft>
+              <a:defRPr sz="1300">
                 <a:solidFill>
                   <a:srgbClr val="F1F5F9"/>
                 </a:solidFill>
@@ -8389,9 +8421,9 @@
           <a:p>
             <a:pPr>
               <a:spcAft>
-                <a:spcPts val="400"/>
-              </a:spcAft>
-              <a:defRPr sz="1400">
+                <a:spcPts val="250"/>
+              </a:spcAft>
+              <a:defRPr sz="1300">
                 <a:solidFill>
                   <a:srgbClr val="F1F5F9"/>
                 </a:solidFill>
@@ -8405,9 +8437,9 @@
           <a:p>
             <a:pPr>
               <a:spcAft>
-                <a:spcPts val="400"/>
-              </a:spcAft>
-              <a:defRPr sz="1400">
+                <a:spcPts val="250"/>
+              </a:spcAft>
+              <a:defRPr sz="1300">
                 <a:solidFill>
                   <a:srgbClr val="F1F5F9"/>
                 </a:solidFill>
@@ -8421,25 +8453,25 @@
           <a:p>
             <a:pPr>
               <a:spcAft>
-                <a:spcPts val="400"/>
-              </a:spcAft>
-              <a:defRPr sz="1400">
-                <a:solidFill>
-                  <a:srgbClr val="F1F5F9"/>
-                </a:solidFill>
-                <a:latin typeface="Segoe UI"/>
-              </a:defRPr>
-            </a:pPr>
-            <a:r>
-              <a:t>• Cross-Encoder Neural Reranker (`rerank.py`): Evaluates candidate chunks against query text using a cross-encoder model. Applies Shifted Sigmoid Scaling to normalize raw logits $L \in [-20, +5]$ into a calibrated $[0.0, 1.0]$ relevance range:</a:t>
-            </a:r>
-          </a:p>
-          <a:p>
-            <a:pPr>
-              <a:spcAft>
-                <a:spcPts val="400"/>
-              </a:spcAft>
-              <a:defRPr sz="1400">
+                <a:spcPts val="250"/>
+              </a:spcAft>
+              <a:defRPr sz="1300">
+                <a:solidFill>
+                  <a:srgbClr val="F1F5F9"/>
+                </a:solidFill>
+                <a:latin typeface="Segoe UI"/>
+              </a:defRPr>
+            </a:pPr>
+            <a:r>
+              <a:t>• Cross-Encoder Neural Reranker (`rerank.py`): Evaluates candidate chunks against query text using a cross-encoder model. Applies Shifted Sigmoid Scaling to normalize raw logits $L \in -20, +5$ into a calibrated $0.0, 1.0$ relevance range:</a:t>
+            </a:r>
+          </a:p>
+          <a:p>
+            <a:pPr>
+              <a:spcAft>
+                <a:spcPts val="250"/>
+              </a:spcAft>
+              <a:defRPr sz="1300">
                 <a:solidFill>
                   <a:srgbClr val="F1F5F9"/>
                 </a:solidFill>
@@ -8485,7 +8517,7 @@
             <a:avLst/>
           </a:prstGeom>
           <a:solidFill>
-            <a:srgbClr val="0F172A"/>
+            <a:srgbClr val="090D16"/>
           </a:solidFill>
           <a:ln>
             <a:noFill/>
@@ -8521,8 +8553,8 @@
         </p:nvSpPr>
         <p:spPr>
           <a:xfrm>
-            <a:off x="731520" y="365760"/>
-            <a:ext cx="10728655" cy="822960"/>
+            <a:off x="548640" y="274320"/>
+            <a:ext cx="11094415" cy="685800"/>
           </a:xfrm>
           <a:prstGeom prst="rect">
             <a:avLst/>
@@ -8530,15 +8562,15 @@
           <a:noFill/>
         </p:spPr>
         <p:txBody>
-          <a:bodyPr wrap="square">
+          <a:bodyPr wrap="square" lIns="0" tIns="0" rIns="0" bIns="0">
             <a:spAutoFit/>
           </a:bodyPr>
           <a:lstStyle/>
           <a:p>
             <a:pPr>
-              <a:defRPr sz="2600" b="1">
-                <a:solidFill>
-                  <a:srgbClr val="818CF8"/>
+              <a:defRPr sz="2200" b="1">
+                <a:solidFill>
+                  <a:srgbClr val="38BDF8"/>
                 </a:solidFill>
                 <a:latin typeface="Segoe UI"/>
               </a:defRPr>
@@ -8557,14 +8589,14 @@
         </p:nvSpPr>
         <p:spPr>
           <a:xfrm>
-            <a:off x="731520" y="1188720"/>
-            <a:ext cx="10728655" cy="36576"/>
+            <a:off x="548640" y="1005840"/>
+            <a:ext cx="11094415" cy="27432"/>
           </a:xfrm>
           <a:prstGeom prst="rect">
             <a:avLst/>
           </a:prstGeom>
           <a:solidFill>
-            <a:srgbClr val="38BDF8"/>
+            <a:srgbClr val="0D9488"/>
           </a:solidFill>
           <a:ln>
             <a:noFill/>
@@ -8600,8 +8632,8 @@
         </p:nvSpPr>
         <p:spPr>
           <a:xfrm>
-            <a:off x="731520" y="1371600"/>
-            <a:ext cx="10728655" cy="4937760"/>
+            <a:off x="548640" y="1143000"/>
+            <a:ext cx="11094415" cy="5303520"/>
           </a:xfrm>
           <a:prstGeom prst="rect">
             <a:avLst/>
@@ -8609,32 +8641,32 @@
           <a:noFill/>
         </p:spPr>
         <p:txBody>
-          <a:bodyPr wrap="square">
+          <a:bodyPr wrap="square" lIns="0" tIns="0" rIns="0" bIns="0">
             <a:spAutoFit/>
           </a:bodyPr>
           <a:lstStyle/>
           <a:p>
             <a:pPr>
               <a:spcAft>
-                <a:spcPts val="800"/>
-              </a:spcAft>
-              <a:defRPr sz="2000" b="1">
-                <a:solidFill>
-                  <a:srgbClr val="94A3B8"/>
-                </a:solidFill>
-                <a:latin typeface="Segoe UI"/>
-              </a:defRPr>
-            </a:pPr>
-            <a:r>
-              <a:t>**Vector-Only vs. Keyword-Only vs. Hybrid Funnel**</a:t>
-            </a:r>
-          </a:p>
-          <a:p>
-            <a:pPr>
-              <a:spcAft>
                 <a:spcPts val="400"/>
               </a:spcAft>
-              <a:defRPr sz="1400">
+              <a:defRPr sz="1700" b="1">
+                <a:solidFill>
+                  <a:srgbClr val="2DD4BF"/>
+                </a:solidFill>
+                <a:latin typeface="Segoe UI"/>
+              </a:defRPr>
+            </a:pPr>
+            <a:r>
+              <a:t>Vector-Only vs. Keyword-Only vs. Hybrid Funnel</a:t>
+            </a:r>
+          </a:p>
+          <a:p>
+            <a:pPr>
+              <a:spcAft>
+                <a:spcPts val="250"/>
+              </a:spcAft>
+              <a:defRPr sz="1300">
                 <a:solidFill>
                   <a:srgbClr val="F1F5F9"/>
                 </a:solidFill>
@@ -8648,9 +8680,9 @@
           <a:p>
             <a:pPr>
               <a:spcAft>
-                <a:spcPts val="400"/>
-              </a:spcAft>
-              <a:defRPr sz="1400">
+                <a:spcPts val="250"/>
+              </a:spcAft>
+              <a:defRPr sz="1300">
                 <a:solidFill>
                   <a:srgbClr val="F1F5F9"/>
                 </a:solidFill>
@@ -8664,9 +8696,9 @@
           <a:p>
             <a:pPr>
               <a:spcAft>
-                <a:spcPts val="400"/>
-              </a:spcAft>
-              <a:defRPr sz="1400">
+                <a:spcPts val="250"/>
+              </a:spcAft>
+              <a:defRPr sz="1300">
                 <a:solidFill>
                   <a:srgbClr val="F1F5F9"/>
                 </a:solidFill>
@@ -8680,9 +8712,9 @@
           <a:p>
             <a:pPr>
               <a:spcAft>
-                <a:spcPts val="400"/>
-              </a:spcAft>
-              <a:defRPr sz="1400">
+                <a:spcPts val="250"/>
+              </a:spcAft>
+              <a:defRPr sz="1300">
                 <a:solidFill>
                   <a:srgbClr val="F1F5F9"/>
                 </a:solidFill>
@@ -8696,9 +8728,9 @@
           <a:p>
             <a:pPr>
               <a:spcAft>
-                <a:spcPts val="400"/>
-              </a:spcAft>
-              <a:defRPr sz="1400">
+                <a:spcPts val="250"/>
+              </a:spcAft>
+              <a:defRPr sz="1300">
                 <a:solidFill>
                   <a:srgbClr val="F1F5F9"/>
                 </a:solidFill>
@@ -8712,9 +8744,9 @@
           <a:p>
             <a:pPr>
               <a:spcAft>
-                <a:spcPts val="400"/>
-              </a:spcAft>
-              <a:defRPr sz="1400">
+                <a:spcPts val="250"/>
+              </a:spcAft>
+              <a:defRPr sz="1300">
                 <a:solidFill>
                   <a:srgbClr val="F1F5F9"/>
                 </a:solidFill>
@@ -8728,9 +8760,9 @@
           <a:p>
             <a:pPr>
               <a:spcAft>
-                <a:spcPts val="400"/>
-              </a:spcAft>
-              <a:defRPr sz="1400">
+                <a:spcPts val="250"/>
+              </a:spcAft>
+              <a:defRPr sz="1300">
                 <a:solidFill>
                   <a:srgbClr val="F1F5F9"/>
                 </a:solidFill>
@@ -8744,33 +8776,33 @@
           <a:p>
             <a:pPr>
               <a:spcAft>
-                <a:spcPts val="600"/>
-              </a:spcAft>
-              <a:defRPr sz="1600" b="1">
-                <a:solidFill>
-                  <a:srgbClr val="94A3B8"/>
-                </a:solidFill>
-                <a:latin typeface="Segoe UI"/>
-              </a:defRPr>
-            </a:pPr>
-            <a:r>
-              <a:t>**The Core Rationale**</a:t>
-            </a:r>
-          </a:p>
-          <a:p>
-            <a:pPr>
-              <a:spcAft>
-                <a:spcPts val="400"/>
-              </a:spcAft>
-              <a:defRPr sz="1400">
-                <a:solidFill>
-                  <a:srgbClr val="F1F5F9"/>
-                </a:solidFill>
-                <a:latin typeface="Segoe UI"/>
-              </a:defRPr>
-            </a:pPr>
-            <a:r>
-              <a:t>Single-retrieval strategies fail under real-world website evaluation. Hybrid retrieval combines the conceptual semantic breadth of dense vectors with the pinpoint exactness of sparse BM25, bounded by neural cross-encoder reranking and relevance gating.</a:t>
+                <a:spcPts val="300"/>
+              </a:spcAft>
+              <a:defRPr sz="1500" b="1">
+                <a:solidFill>
+                  <a:srgbClr val="2DD4BF"/>
+                </a:solidFill>
+                <a:latin typeface="Segoe UI"/>
+              </a:defRPr>
+            </a:pPr>
+            <a:r>
+              <a:t>The Core Rationale</a:t>
+            </a:r>
+          </a:p>
+          <a:p>
+            <a:pPr>
+              <a:spcAft>
+                <a:spcPts val="250"/>
+              </a:spcAft>
+              <a:defRPr sz="1300">
+                <a:solidFill>
+                  <a:srgbClr val="F1F5F9"/>
+                </a:solidFill>
+                <a:latin typeface="Segoe UI"/>
+              </a:defRPr>
+            </a:pPr>
+            <a:r>
+              <a:t>Single-retrieval strategies fail under real-world website evaluation. Hybrid retrieval combines conceptual semantic breadth with exact keyword matching, bounded by neural reranking.</a:t>
             </a:r>
           </a:p>
         </p:txBody>
@@ -8808,7 +8840,7 @@
             <a:avLst/>
           </a:prstGeom>
           <a:solidFill>
-            <a:srgbClr val="0F172A"/>
+            <a:srgbClr val="090D16"/>
           </a:solidFill>
           <a:ln>
             <a:noFill/>
@@ -8844,8 +8876,8 @@
         </p:nvSpPr>
         <p:spPr>
           <a:xfrm>
-            <a:off x="731520" y="365760"/>
-            <a:ext cx="10728655" cy="822960"/>
+            <a:off x="548640" y="274320"/>
+            <a:ext cx="11094415" cy="685800"/>
           </a:xfrm>
           <a:prstGeom prst="rect">
             <a:avLst/>
@@ -8853,15 +8885,15 @@
           <a:noFill/>
         </p:spPr>
         <p:txBody>
-          <a:bodyPr wrap="square">
+          <a:bodyPr wrap="square" lIns="0" tIns="0" rIns="0" bIns="0">
             <a:spAutoFit/>
           </a:bodyPr>
           <a:lstStyle/>
           <a:p>
             <a:pPr>
-              <a:defRPr sz="2600" b="1">
-                <a:solidFill>
-                  <a:srgbClr val="818CF8"/>
+              <a:defRPr sz="2200" b="1">
+                <a:solidFill>
+                  <a:srgbClr val="38BDF8"/>
                 </a:solidFill>
                 <a:latin typeface="Segoe UI"/>
               </a:defRPr>
@@ -8880,14 +8912,14 @@
         </p:nvSpPr>
         <p:spPr>
           <a:xfrm>
-            <a:off x="731520" y="1188720"/>
-            <a:ext cx="10728655" cy="36576"/>
+            <a:off x="548640" y="1005840"/>
+            <a:ext cx="11094415" cy="27432"/>
           </a:xfrm>
           <a:prstGeom prst="rect">
             <a:avLst/>
           </a:prstGeom>
           <a:solidFill>
-            <a:srgbClr val="38BDF8"/>
+            <a:srgbClr val="0D9488"/>
           </a:solidFill>
           <a:ln>
             <a:noFill/>
@@ -8923,8 +8955,8 @@
         </p:nvSpPr>
         <p:spPr>
           <a:xfrm>
-            <a:off x="731520" y="1371600"/>
-            <a:ext cx="10728655" cy="4937760"/>
+            <a:off x="548640" y="1143000"/>
+            <a:ext cx="11094415" cy="5303520"/>
           </a:xfrm>
           <a:prstGeom prst="rect">
             <a:avLst/>
@@ -8932,32 +8964,32 @@
           <a:noFill/>
         </p:spPr>
         <p:txBody>
-          <a:bodyPr wrap="square">
+          <a:bodyPr wrap="square" lIns="0" tIns="0" rIns="0" bIns="0">
             <a:spAutoFit/>
           </a:bodyPr>
           <a:lstStyle/>
           <a:p>
             <a:pPr>
               <a:spcAft>
-                <a:spcPts val="800"/>
-              </a:spcAft>
-              <a:defRPr sz="2000" b="1">
-                <a:solidFill>
-                  <a:srgbClr val="94A3B8"/>
-                </a:solidFill>
-                <a:latin typeface="Segoe UI"/>
-              </a:defRPr>
-            </a:pPr>
-            <a:r>
-              <a:t>**Extractive Question Answering (`app/rag/qa.py`)**</a:t>
-            </a:r>
-          </a:p>
-          <a:p>
-            <a:pPr>
-              <a:spcAft>
                 <a:spcPts val="400"/>
               </a:spcAft>
-              <a:defRPr sz="1400">
+              <a:defRPr sz="1700" b="1">
+                <a:solidFill>
+                  <a:srgbClr val="2DD4BF"/>
+                </a:solidFill>
+                <a:latin typeface="Segoe UI"/>
+              </a:defRPr>
+            </a:pPr>
+            <a:r>
+              <a:t>Extractive Question Answering (`app/rag/qa.py`)</a:t>
+            </a:r>
+          </a:p>
+          <a:p>
+            <a:pPr>
+              <a:spcAft>
+                <a:spcPts val="250"/>
+              </a:spcAft>
+              <a:defRPr sz="1300">
                 <a:solidFill>
                   <a:srgbClr val="F1F5F9"/>
                 </a:solidFill>
@@ -8971,9 +9003,9 @@
           <a:p>
             <a:pPr>
               <a:spcAft>
-                <a:spcPts val="400"/>
-              </a:spcAft>
-              <a:defRPr sz="1400">
+                <a:spcPts val="250"/>
+              </a:spcAft>
+              <a:defRPr sz="1300">
                 <a:solidFill>
                   <a:srgbClr val="F1F5F9"/>
                 </a:solidFill>
@@ -8987,9 +9019,9 @@
           <a:p>
             <a:pPr>
               <a:spcAft>
-                <a:spcPts val="400"/>
-              </a:spcAft>
-              <a:defRPr sz="1400">
+                <a:spcPts val="250"/>
+              </a:spcAft>
+              <a:defRPr sz="1300">
                 <a:solidFill>
                   <a:srgbClr val="F1F5F9"/>
                 </a:solidFill>
@@ -9003,9 +9035,9 @@
           <a:p>
             <a:pPr>
               <a:spcAft>
-                <a:spcPts val="400"/>
-              </a:spcAft>
-              <a:defRPr sz="1400">
+                <a:spcPts val="250"/>
+              </a:spcAft>
+              <a:defRPr sz="1300">
                 <a:solidFill>
                   <a:srgbClr val="F1F5F9"/>
                 </a:solidFill>
@@ -9019,9 +9051,9 @@
           <a:p>
             <a:pPr>
               <a:spcAft>
-                <a:spcPts val="400"/>
-              </a:spcAft>
-              <a:defRPr sz="1400">
+                <a:spcPts val="250"/>
+              </a:spcAft>
+              <a:defRPr sz="1300">
                 <a:solidFill>
                   <a:srgbClr val="F1F5F9"/>
                 </a:solidFill>
@@ -9035,41 +9067,41 @@
           <a:p>
             <a:pPr>
               <a:spcAft>
-                <a:spcPts val="400"/>
-              </a:spcAft>
-              <a:defRPr sz="1400">
-                <a:solidFill>
-                  <a:srgbClr val="F1F5F9"/>
-                </a:solidFill>
-                <a:latin typeface="Segoe UI"/>
-              </a:defRPr>
-            </a:pPr>
-            <a:r>
-              <a:t>4. Fail-Closed Threshold Gate: If highest score is below $0.30$, returns a clear refutation response: *"Insufficient evidence found in public domain pages to answer this question accurately."*</a:t>
-            </a:r>
-          </a:p>
-          <a:p>
-            <a:pPr>
-              <a:spcAft>
-                <a:spcPts val="400"/>
-              </a:spcAft>
-              <a:defRPr sz="1400">
-                <a:solidFill>
-                  <a:srgbClr val="F1F5F9"/>
-                </a:solidFill>
-                <a:latin typeface="Segoe UI"/>
-              </a:defRPr>
-            </a:pPr>
-            <a:r>
-              <a:t>5. If relevance is sufficient, passes retrieved chunks + explicit prompt instructions to LLM to synthesize a grounded answer.</a:t>
-            </a:r>
-          </a:p>
-          <a:p>
-            <a:pPr>
-              <a:spcAft>
-                <a:spcPts val="400"/>
-              </a:spcAft>
-              <a:defRPr sz="1400">
+                <a:spcPts val="250"/>
+              </a:spcAft>
+              <a:defRPr sz="1300">
+                <a:solidFill>
+                  <a:srgbClr val="F1F5F9"/>
+                </a:solidFill>
+                <a:latin typeface="Segoe UI"/>
+              </a:defRPr>
+            </a:pPr>
+            <a:r>
+              <a:t>4. Fail-Closed Threshold Gate: If highest score is below $0.30$, returns refutation: *"Insufficient evidence found in public domain pages to answer this question accurately."*</a:t>
+            </a:r>
+          </a:p>
+          <a:p>
+            <a:pPr>
+              <a:spcAft>
+                <a:spcPts val="250"/>
+              </a:spcAft>
+              <a:defRPr sz="1300">
+                <a:solidFill>
+                  <a:srgbClr val="F1F5F9"/>
+                </a:solidFill>
+                <a:latin typeface="Segoe UI"/>
+              </a:defRPr>
+            </a:pPr>
+            <a:r>
+              <a:t>5. If relevance is sufficient, passes retrieved chunks + prompt instructions to LLM for answer synthesis.</a:t>
+            </a:r>
+          </a:p>
+          <a:p>
+            <a:pPr>
+              <a:spcAft>
+                <a:spcPts val="250"/>
+              </a:spcAft>
+              <a:defRPr sz="1300">
                 <a:solidFill>
                   <a:srgbClr val="F1F5F9"/>
                 </a:solidFill>

</xml_diff>